<commit_message>
vault backup: 2026-08-11 15:26:00
</commit_message>
<xml_diff>
--- a/_기능별 경로 가이드 — 실행 계획.pptx
+++ b/_기능별 경로 가이드 — 실행 계획.pptx
@@ -6771,7 +6771,7 @@
           </p:nvPr>
         </p:nvGraphicFramePr>
         <p:xfrm>
-          <a:off x="777240" y="2240280"/>
+          <a:off x="777240" y="2194560"/>
           <a:ext cx="10637215" cy="914400"/>
         </p:xfrm>
         <a:graphic>
@@ -6779,12 +6779,11 @@
             <a:tbl>
               <a:tblPr/>
               <a:tblGrid>
-                <a:gridCol w="1874520"/>
-                <a:gridCol w="2286000"/>
-                <a:gridCol w="5212080"/>
-                <a:gridCol w="1261872"/>
+                <a:gridCol w="1554480"/>
+                <a:gridCol w="3108960"/>
+                <a:gridCol w="5971032"/>
               </a:tblGrid>
-              <a:tr h="475488">
+              <a:tr h="438912">
                 <a:tc>
                   <a:txBody>
                     <a:bodyPr/>
@@ -6794,7 +6793,7 @@
                         <a:buNone/>
                       </a:pPr>
                       <a:r>
-                        <a:rPr lang="en-US" sz="1250" dirty="0">
+                        <a:rPr lang="en-US" sz="1200" dirty="0">
                           <a:solidFill>
                             <a:srgbClr val="FFFFFF"/>
                           </a:solidFill>
@@ -6802,9 +6801,9 @@
                           <a:ea typeface="Pretendard SemiBold" pitchFamily="34" charset="-122"/>
                           <a:cs typeface="Pretendard SemiBold" pitchFamily="34" charset="-120"/>
                         </a:rPr>
-                        <a:t>기능</a:t>
+                        <a:t>구분</a:t>
                       </a:r>
-                      <a:endParaRPr lang="en-US" sz="1250" dirty="0">
+                      <a:endParaRPr lang="en-US" sz="1200" dirty="0">
                         <a:latin typeface="Pretendard SemiBold" charset="0"/>
                         <a:ea typeface="Pretendard SemiBold" charset="0"/>
                         <a:cs typeface="Pretendard SemiBold" charset="0"/>
@@ -6862,7 +6861,7 @@
                         <a:buNone/>
                       </a:pPr>
                       <a:r>
-                        <a:rPr lang="en-US" sz="1250" dirty="0">
+                        <a:rPr lang="en-US" sz="1200" dirty="0">
                           <a:solidFill>
                             <a:srgbClr val="FFFFFF"/>
                           </a:solidFill>
@@ -6872,7 +6871,7 @@
                         </a:rPr>
                         <a:t>이렇게 말하면</a:t>
                       </a:r>
-                      <a:endParaRPr lang="en-US" sz="1250" dirty="0">
+                      <a:endParaRPr lang="en-US" sz="1200" dirty="0">
                         <a:latin typeface="Pretendard SemiBold" charset="0"/>
                         <a:ea typeface="Pretendard SemiBold" charset="0"/>
                         <a:cs typeface="Pretendard SemiBold" charset="0"/>
@@ -6930,7 +6929,7 @@
                         <a:buNone/>
                       </a:pPr>
                       <a:r>
-                        <a:rPr lang="en-US" sz="1250" dirty="0">
+                        <a:rPr lang="en-US" sz="1200" dirty="0">
                           <a:solidFill>
                             <a:srgbClr val="FFFFFF"/>
                           </a:solidFill>
@@ -6940,7 +6939,7 @@
                         </a:rPr>
                         <a:t>정본 파일·섹션 (검증된 경로)</a:t>
                       </a:r>
-                      <a:endParaRPr lang="en-US" sz="1250" dirty="0">
+                      <a:endParaRPr lang="en-US" sz="1200" dirty="0">
                         <a:latin typeface="Pretendard SemiBold" charset="0"/>
                         <a:ea typeface="Pretendard SemiBold" charset="0"/>
                         <a:cs typeface="Pretendard SemiBold" charset="0"/>
@@ -6986,6 +6985,76 @@
                     </a:lnB>
                     <a:solidFill>
                       <a:srgbClr val="1D1D1F"/>
+                    </a:solidFill>
+                  </a:tcPr>
+                </a:tc>
+              </a:tr>
+              <a:tr h="438912">
+                <a:tc>
+                  <a:txBody>
+                    <a:bodyPr/>
+                    <a:lstStyle/>
+                    <a:p>
+                      <a:pPr indent="0" marL="0">
+                        <a:buNone/>
+                      </a:pPr>
+                      <a:r>
+                        <a:rPr lang="en-US" sz="1150" dirty="0">
+                          <a:solidFill>
+                            <a:srgbClr val="6C4CFF"/>
+                          </a:solidFill>
+                          <a:latin typeface="Pretendard SemiBold" pitchFamily="34" charset="0"/>
+                          <a:ea typeface="Pretendard SemiBold" pitchFamily="34" charset="-122"/>
+                          <a:cs typeface="Pretendard SemiBold" pitchFamily="34" charset="-120"/>
+                        </a:rPr>
+                        <a:t>CdBd 기능</a:t>
+                      </a:r>
+                      <a:endParaRPr lang="en-US" sz="1150" dirty="0">
+                        <a:latin typeface="Pretendard SemiBold" charset="0"/>
+                        <a:ea typeface="Pretendard SemiBold" charset="0"/>
+                        <a:cs typeface="Pretendard SemiBold" charset="0"/>
+                      </a:endParaRPr>
+                    </a:p>
+                  </a:txBody>
+                  <a:tcPr marL="101600" marR="101600" marT="38100" marB="38100" anchor="ctr">
+                    <a:lnL w="6350" cap="flat" cmpd="sng" algn="ctr">
+                      <a:solidFill>
+                        <a:srgbClr val="E5E7EB"/>
+                      </a:solidFill>
+                      <a:prstDash val="solid"/>
+                      <a:round/>
+                      <a:headEnd type="none" w="med" len="med"/>
+                      <a:tailEnd type="none" w="med" len="med"/>
+                    </a:lnL>
+                    <a:lnR w="6350" cap="flat" cmpd="sng" algn="ctr">
+                      <a:solidFill>
+                        <a:srgbClr val="E5E7EB"/>
+                      </a:solidFill>
+                      <a:prstDash val="solid"/>
+                      <a:round/>
+                      <a:headEnd type="none" w="med" len="med"/>
+                      <a:tailEnd type="none" w="med" len="med"/>
+                    </a:lnR>
+                    <a:lnT w="6350" cap="flat" cmpd="sng" algn="ctr">
+                      <a:solidFill>
+                        <a:srgbClr val="E5E7EB"/>
+                      </a:solidFill>
+                      <a:prstDash val="solid"/>
+                      <a:round/>
+                      <a:headEnd type="none" w="med" len="med"/>
+                      <a:tailEnd type="none" w="med" len="med"/>
+                    </a:lnT>
+                    <a:lnB w="6350" cap="flat" cmpd="sng" algn="ctr">
+                      <a:solidFill>
+                        <a:srgbClr val="E5E7EB"/>
+                      </a:solidFill>
+                      <a:prstDash val="solid"/>
+                      <a:round/>
+                      <a:headEnd type="none" w="med" len="med"/>
+                      <a:tailEnd type="none" w="med" len="med"/>
+                    </a:lnB>
+                    <a:solidFill>
+                      <a:srgbClr val="F5F5F7"/>
                     </a:solidFill>
                   </a:tcPr>
                 </a:tc>
@@ -6998,90 +7067,20 @@
                         <a:buNone/>
                       </a:pPr>
                       <a:r>
-                        <a:rPr lang="en-US" sz="1250" dirty="0">
-                          <a:solidFill>
-                            <a:srgbClr val="FFFFFF"/>
-                          </a:solidFill>
-                          <a:latin typeface="Pretendard SemiBold" pitchFamily="34" charset="0"/>
-                          <a:ea typeface="Pretendard SemiBold" pitchFamily="34" charset="-122"/>
-                          <a:cs typeface="Pretendard SemiBold" pitchFamily="34" charset="-120"/>
-                        </a:rPr>
-                        <a:t>스킬화</a:t>
-                      </a:r>
-                      <a:endParaRPr lang="en-US" sz="1250" dirty="0">
-                        <a:latin typeface="Pretendard SemiBold" charset="0"/>
-                        <a:ea typeface="Pretendard SemiBold" charset="0"/>
-                        <a:cs typeface="Pretendard SemiBold" charset="0"/>
-                      </a:endParaRPr>
-                    </a:p>
-                  </a:txBody>
-                  <a:tcPr marL="101600" marR="101600" marT="38100" marB="38100" anchor="ctr">
-                    <a:lnL w="6350" cap="flat" cmpd="sng" algn="ctr">
-                      <a:solidFill>
-                        <a:srgbClr val="E5E7EB"/>
-                      </a:solidFill>
-                      <a:prstDash val="solid"/>
-                      <a:round/>
-                      <a:headEnd type="none" w="med" len="med"/>
-                      <a:tailEnd type="none" w="med" len="med"/>
-                    </a:lnL>
-                    <a:lnR w="6350" cap="flat" cmpd="sng" algn="ctr">
-                      <a:solidFill>
-                        <a:srgbClr val="E5E7EB"/>
-                      </a:solidFill>
-                      <a:prstDash val="solid"/>
-                      <a:round/>
-                      <a:headEnd type="none" w="med" len="med"/>
-                      <a:tailEnd type="none" w="med" len="med"/>
-                    </a:lnR>
-                    <a:lnT w="6350" cap="flat" cmpd="sng" algn="ctr">
-                      <a:solidFill>
-                        <a:srgbClr val="E5E7EB"/>
-                      </a:solidFill>
-                      <a:prstDash val="solid"/>
-                      <a:round/>
-                      <a:headEnd type="none" w="med" len="med"/>
-                      <a:tailEnd type="none" w="med" len="med"/>
-                    </a:lnT>
-                    <a:lnB w="6350" cap="flat" cmpd="sng" algn="ctr">
-                      <a:solidFill>
-                        <a:srgbClr val="E5E7EB"/>
-                      </a:solidFill>
-                      <a:prstDash val="solid"/>
-                      <a:round/>
-                      <a:headEnd type="none" w="med" len="med"/>
-                      <a:tailEnd type="none" w="med" len="med"/>
-                    </a:lnB>
-                    <a:solidFill>
-                      <a:srgbClr val="1D1D1F"/>
-                    </a:solidFill>
-                  </a:tcPr>
-                </a:tc>
-              </a:tr>
-              <a:tr h="475488">
-                <a:tc>
-                  <a:txBody>
-                    <a:bodyPr/>
-                    <a:lstStyle/>
-                    <a:p>
-                      <a:pPr indent="0" marL="0">
-                        <a:buNone/>
-                      </a:pPr>
-                      <a:r>
-                        <a:rPr lang="en-US" sz="1200" dirty="0">
+                        <a:rPr lang="en-US" sz="1150" dirty="0">
                           <a:solidFill>
                             <a:srgbClr val="1D1D1F"/>
                           </a:solidFill>
-                          <a:latin typeface="Pretendard SemiBold" pitchFamily="34" charset="0"/>
-                          <a:ea typeface="Pretendard SemiBold" pitchFamily="34" charset="-122"/>
-                          <a:cs typeface="Pretendard SemiBold" pitchFamily="34" charset="-120"/>
+                          <a:latin typeface="Pretendard" pitchFamily="34" charset="0"/>
+                          <a:ea typeface="Pretendard" pitchFamily="34" charset="-122"/>
+                          <a:cs typeface="Pretendard" pitchFamily="34" charset="-120"/>
                         </a:rPr>
-                        <a:t>룩북 시안 제작</a:t>
+                        <a:t>"CdBd에 올려줘" (콘텐츠 등록)</a:t>
                       </a:r>
-                      <a:endParaRPr lang="en-US" sz="1200" dirty="0">
-                        <a:latin typeface="Pretendard SemiBold" charset="0"/>
-                        <a:ea typeface="Pretendard SemiBold" charset="0"/>
-                        <a:cs typeface="Pretendard SemiBold" charset="0"/>
+                      <a:endParaRPr lang="en-US" sz="1150" dirty="0">
+                        <a:latin typeface="Pretendard" charset="0"/>
+                        <a:ea typeface="Pretendard" charset="0"/>
+                        <a:cs typeface="Pretendard" charset="0"/>
                       </a:endParaRPr>
                     </a:p>
                   </a:txBody>
@@ -7144,9 +7143,353 @@
                           <a:ea typeface="Pretendard" pitchFamily="34" charset="-122"/>
                           <a:cs typeface="Pretendard" pitchFamily="34" charset="-120"/>
                         </a:rPr>
+                        <a:t>룩북/1. 제작 프로세스/1-4. CdBd 콘텐츠.md §등록 워크플로우</a:t>
+                      </a:r>
+                      <a:endParaRPr lang="en-US" sz="1100" dirty="0">
+                        <a:latin typeface="Pretendard" charset="0"/>
+                        <a:ea typeface="Pretendard" charset="0"/>
+                        <a:cs typeface="Pretendard" charset="0"/>
+                      </a:endParaRPr>
+                    </a:p>
+                  </a:txBody>
+                  <a:tcPr marL="101600" marR="101600" marT="38100" marB="38100" anchor="ctr">
+                    <a:lnL w="6350" cap="flat" cmpd="sng" algn="ctr">
+                      <a:solidFill>
+                        <a:srgbClr val="E5E7EB"/>
+                      </a:solidFill>
+                      <a:prstDash val="solid"/>
+                      <a:round/>
+                      <a:headEnd type="none" w="med" len="med"/>
+                      <a:tailEnd type="none" w="med" len="med"/>
+                    </a:lnL>
+                    <a:lnR w="6350" cap="flat" cmpd="sng" algn="ctr">
+                      <a:solidFill>
+                        <a:srgbClr val="E5E7EB"/>
+                      </a:solidFill>
+                      <a:prstDash val="solid"/>
+                      <a:round/>
+                      <a:headEnd type="none" w="med" len="med"/>
+                      <a:tailEnd type="none" w="med" len="med"/>
+                    </a:lnR>
+                    <a:lnT w="6350" cap="flat" cmpd="sng" algn="ctr">
+                      <a:solidFill>
+                        <a:srgbClr val="E5E7EB"/>
+                      </a:solidFill>
+                      <a:prstDash val="solid"/>
+                      <a:round/>
+                      <a:headEnd type="none" w="med" len="med"/>
+                      <a:tailEnd type="none" w="med" len="med"/>
+                    </a:lnT>
+                    <a:lnB w="6350" cap="flat" cmpd="sng" algn="ctr">
+                      <a:solidFill>
+                        <a:srgbClr val="E5E7EB"/>
+                      </a:solidFill>
+                      <a:prstDash val="solid"/>
+                      <a:round/>
+                      <a:headEnd type="none" w="med" len="med"/>
+                      <a:tailEnd type="none" w="med" len="med"/>
+                    </a:lnB>
+                    <a:solidFill>
+                      <a:srgbClr val="F5F5F7"/>
+                    </a:solidFill>
+                  </a:tcPr>
+                </a:tc>
+              </a:tr>
+              <a:tr h="438912">
+                <a:tc>
+                  <a:txBody>
+                    <a:bodyPr/>
+                    <a:lstStyle/>
+                    <a:p>
+                      <a:pPr indent="0" marL="0">
+                        <a:buNone/>
+                      </a:pPr>
+                      <a:r>
+                        <a:rPr lang="en-US" sz="1150" dirty="0">
+                          <a:solidFill>
+                            <a:srgbClr val="6C4CFF"/>
+                          </a:solidFill>
+                          <a:latin typeface="Pretendard SemiBold" pitchFamily="34" charset="0"/>
+                          <a:ea typeface="Pretendard SemiBold" pitchFamily="34" charset="-122"/>
+                          <a:cs typeface="Pretendard SemiBold" pitchFamily="34" charset="-120"/>
+                        </a:rPr>
+                        <a:t>CdBd 기능</a:t>
+                      </a:r>
+                      <a:endParaRPr lang="en-US" sz="1150" dirty="0">
+                        <a:latin typeface="Pretendard SemiBold" charset="0"/>
+                        <a:ea typeface="Pretendard SemiBold" charset="0"/>
+                        <a:cs typeface="Pretendard SemiBold" charset="0"/>
+                      </a:endParaRPr>
+                    </a:p>
+                  </a:txBody>
+                  <a:tcPr marL="101600" marR="101600" marT="38100" marB="38100" anchor="ctr">
+                    <a:lnL w="6350" cap="flat" cmpd="sng" algn="ctr">
+                      <a:solidFill>
+                        <a:srgbClr val="E5E7EB"/>
+                      </a:solidFill>
+                      <a:prstDash val="solid"/>
+                      <a:round/>
+                      <a:headEnd type="none" w="med" len="med"/>
+                      <a:tailEnd type="none" w="med" len="med"/>
+                    </a:lnL>
+                    <a:lnR w="6350" cap="flat" cmpd="sng" algn="ctr">
+                      <a:solidFill>
+                        <a:srgbClr val="E5E7EB"/>
+                      </a:solidFill>
+                      <a:prstDash val="solid"/>
+                      <a:round/>
+                      <a:headEnd type="none" w="med" len="med"/>
+                      <a:tailEnd type="none" w="med" len="med"/>
+                    </a:lnR>
+                    <a:lnT w="6350" cap="flat" cmpd="sng" algn="ctr">
+                      <a:solidFill>
+                        <a:srgbClr val="E5E7EB"/>
+                      </a:solidFill>
+                      <a:prstDash val="solid"/>
+                      <a:round/>
+                      <a:headEnd type="none" w="med" len="med"/>
+                      <a:tailEnd type="none" w="med" len="med"/>
+                    </a:lnT>
+                    <a:lnB w="6350" cap="flat" cmpd="sng" algn="ctr">
+                      <a:solidFill>
+                        <a:srgbClr val="E5E7EB"/>
+                      </a:solidFill>
+                      <a:prstDash val="solid"/>
+                      <a:round/>
+                      <a:headEnd type="none" w="med" len="med"/>
+                      <a:tailEnd type="none" w="med" len="med"/>
+                    </a:lnB>
+                    <a:solidFill>
+                      <a:srgbClr val="FFFFFF"/>
+                    </a:solidFill>
+                  </a:tcPr>
+                </a:tc>
+                <a:tc>
+                  <a:txBody>
+                    <a:bodyPr/>
+                    <a:lstStyle/>
+                    <a:p>
+                      <a:pPr indent="0" marL="0">
+                        <a:buNone/>
+                      </a:pPr>
+                      <a:r>
+                        <a:rPr lang="en-US" sz="1150" dirty="0">
+                          <a:solidFill>
+                            <a:srgbClr val="1D1D1F"/>
+                          </a:solidFill>
+                          <a:latin typeface="Pretendard" pitchFamily="34" charset="0"/>
+                          <a:ea typeface="Pretendard" pitchFamily="34" charset="-122"/>
+                          <a:cs typeface="Pretendard" pitchFamily="34" charset="-120"/>
+                        </a:rPr>
+                        <a:t>"이미지 라이브러리에 올려줘"</a:t>
+                      </a:r>
+                      <a:endParaRPr lang="en-US" sz="1150" dirty="0">
+                        <a:latin typeface="Pretendard" charset="0"/>
+                        <a:ea typeface="Pretendard" charset="0"/>
+                        <a:cs typeface="Pretendard" charset="0"/>
+                      </a:endParaRPr>
+                    </a:p>
+                  </a:txBody>
+                  <a:tcPr marL="101600" marR="101600" marT="38100" marB="38100" anchor="ctr">
+                    <a:lnL w="6350" cap="flat" cmpd="sng" algn="ctr">
+                      <a:solidFill>
+                        <a:srgbClr val="E5E7EB"/>
+                      </a:solidFill>
+                      <a:prstDash val="solid"/>
+                      <a:round/>
+                      <a:headEnd type="none" w="med" len="med"/>
+                      <a:tailEnd type="none" w="med" len="med"/>
+                    </a:lnL>
+                    <a:lnR w="6350" cap="flat" cmpd="sng" algn="ctr">
+                      <a:solidFill>
+                        <a:srgbClr val="E5E7EB"/>
+                      </a:solidFill>
+                      <a:prstDash val="solid"/>
+                      <a:round/>
+                      <a:headEnd type="none" w="med" len="med"/>
+                      <a:tailEnd type="none" w="med" len="med"/>
+                    </a:lnR>
+                    <a:lnT w="6350" cap="flat" cmpd="sng" algn="ctr">
+                      <a:solidFill>
+                        <a:srgbClr val="E5E7EB"/>
+                      </a:solidFill>
+                      <a:prstDash val="solid"/>
+                      <a:round/>
+                      <a:headEnd type="none" w="med" len="med"/>
+                      <a:tailEnd type="none" w="med" len="med"/>
+                    </a:lnT>
+                    <a:lnB w="6350" cap="flat" cmpd="sng" algn="ctr">
+                      <a:solidFill>
+                        <a:srgbClr val="E5E7EB"/>
+                      </a:solidFill>
+                      <a:prstDash val="solid"/>
+                      <a:round/>
+                      <a:headEnd type="none" w="med" len="med"/>
+                      <a:tailEnd type="none" w="med" len="med"/>
+                    </a:lnB>
+                    <a:solidFill>
+                      <a:srgbClr val="FFFFFF"/>
+                    </a:solidFill>
+                  </a:tcPr>
+                </a:tc>
+                <a:tc>
+                  <a:txBody>
+                    <a:bodyPr/>
+                    <a:lstStyle/>
+                    <a:p>
+                      <a:pPr indent="0" marL="0">
+                        <a:buNone/>
+                      </a:pPr>
+                      <a:r>
+                        <a:rPr lang="en-US" sz="1100" dirty="0">
+                          <a:solidFill>
+                            <a:srgbClr val="55555A"/>
+                          </a:solidFill>
+                          <a:latin typeface="Pretendard" pitchFamily="34" charset="0"/>
+                          <a:ea typeface="Pretendard" pitchFamily="34" charset="-122"/>
+                          <a:cs typeface="Pretendard" pitchFamily="34" charset="-120"/>
+                        </a:rPr>
+                        <a:t>CLAUDE.md §이미지 라이브러리 (image_library.py)</a:t>
+                      </a:r>
+                      <a:endParaRPr lang="en-US" sz="1100" dirty="0">
+                        <a:latin typeface="Pretendard" charset="0"/>
+                        <a:ea typeface="Pretendard" charset="0"/>
+                        <a:cs typeface="Pretendard" charset="0"/>
+                      </a:endParaRPr>
+                    </a:p>
+                  </a:txBody>
+                  <a:tcPr marL="101600" marR="101600" marT="38100" marB="38100" anchor="ctr">
+                    <a:lnL w="6350" cap="flat" cmpd="sng" algn="ctr">
+                      <a:solidFill>
+                        <a:srgbClr val="E5E7EB"/>
+                      </a:solidFill>
+                      <a:prstDash val="solid"/>
+                      <a:round/>
+                      <a:headEnd type="none" w="med" len="med"/>
+                      <a:tailEnd type="none" w="med" len="med"/>
+                    </a:lnL>
+                    <a:lnR w="6350" cap="flat" cmpd="sng" algn="ctr">
+                      <a:solidFill>
+                        <a:srgbClr val="E5E7EB"/>
+                      </a:solidFill>
+                      <a:prstDash val="solid"/>
+                      <a:round/>
+                      <a:headEnd type="none" w="med" len="med"/>
+                      <a:tailEnd type="none" w="med" len="med"/>
+                    </a:lnR>
+                    <a:lnT w="6350" cap="flat" cmpd="sng" algn="ctr">
+                      <a:solidFill>
+                        <a:srgbClr val="E5E7EB"/>
+                      </a:solidFill>
+                      <a:prstDash val="solid"/>
+                      <a:round/>
+                      <a:headEnd type="none" w="med" len="med"/>
+                      <a:tailEnd type="none" w="med" len="med"/>
+                    </a:lnT>
+                    <a:lnB w="6350" cap="flat" cmpd="sng" algn="ctr">
+                      <a:solidFill>
+                        <a:srgbClr val="E5E7EB"/>
+                      </a:solidFill>
+                      <a:prstDash val="solid"/>
+                      <a:round/>
+                      <a:headEnd type="none" w="med" len="med"/>
+                      <a:tailEnd type="none" w="med" len="med"/>
+                    </a:lnB>
+                    <a:solidFill>
+                      <a:srgbClr val="FFFFFF"/>
+                    </a:solidFill>
+                  </a:tcPr>
+                </a:tc>
+              </a:tr>
+              <a:tr h="438912">
+                <a:tc>
+                  <a:txBody>
+                    <a:bodyPr/>
+                    <a:lstStyle/>
+                    <a:p>
+                      <a:pPr indent="0" marL="0">
+                        <a:buNone/>
+                      </a:pPr>
+                      <a:r>
+                        <a:rPr lang="en-US" sz="1150" dirty="0">
+                          <a:solidFill>
+                            <a:srgbClr val="6E6E73"/>
+                          </a:solidFill>
+                          <a:latin typeface="Pretendard SemiBold" pitchFamily="34" charset="0"/>
+                          <a:ea typeface="Pretendard SemiBold" pitchFamily="34" charset="-122"/>
+                          <a:cs typeface="Pretendard SemiBold" pitchFamily="34" charset="-120"/>
+                        </a:rPr>
+                        <a:t>Figma 제작</a:t>
+                      </a:r>
+                      <a:endParaRPr lang="en-US" sz="1150" dirty="0">
+                        <a:latin typeface="Pretendard SemiBold" charset="0"/>
+                        <a:ea typeface="Pretendard SemiBold" charset="0"/>
+                        <a:cs typeface="Pretendard SemiBold" charset="0"/>
+                      </a:endParaRPr>
+                    </a:p>
+                  </a:txBody>
+                  <a:tcPr marL="101600" marR="101600" marT="38100" marB="38100" anchor="ctr">
+                    <a:lnL w="6350" cap="flat" cmpd="sng" algn="ctr">
+                      <a:solidFill>
+                        <a:srgbClr val="E5E7EB"/>
+                      </a:solidFill>
+                      <a:prstDash val="solid"/>
+                      <a:round/>
+                      <a:headEnd type="none" w="med" len="med"/>
+                      <a:tailEnd type="none" w="med" len="med"/>
+                    </a:lnL>
+                    <a:lnR w="6350" cap="flat" cmpd="sng" algn="ctr">
+                      <a:solidFill>
+                        <a:srgbClr val="E5E7EB"/>
+                      </a:solidFill>
+                      <a:prstDash val="solid"/>
+                      <a:round/>
+                      <a:headEnd type="none" w="med" len="med"/>
+                      <a:tailEnd type="none" w="med" len="med"/>
+                    </a:lnR>
+                    <a:lnT w="6350" cap="flat" cmpd="sng" algn="ctr">
+                      <a:solidFill>
+                        <a:srgbClr val="E5E7EB"/>
+                      </a:solidFill>
+                      <a:prstDash val="solid"/>
+                      <a:round/>
+                      <a:headEnd type="none" w="med" len="med"/>
+                      <a:tailEnd type="none" w="med" len="med"/>
+                    </a:lnT>
+                    <a:lnB w="6350" cap="flat" cmpd="sng" algn="ctr">
+                      <a:solidFill>
+                        <a:srgbClr val="E5E7EB"/>
+                      </a:solidFill>
+                      <a:prstDash val="solid"/>
+                      <a:round/>
+                      <a:headEnd type="none" w="med" len="med"/>
+                      <a:tailEnd type="none" w="med" len="med"/>
+                    </a:lnB>
+                    <a:solidFill>
+                      <a:srgbClr val="F5F5F7"/>
+                    </a:solidFill>
+                  </a:tcPr>
+                </a:tc>
+                <a:tc>
+                  <a:txBody>
+                    <a:bodyPr/>
+                    <a:lstStyle/>
+                    <a:p>
+                      <a:pPr indent="0" marL="0">
+                        <a:buNone/>
+                      </a:pPr>
+                      <a:r>
+                        <a:rPr lang="en-US" sz="1150" dirty="0">
+                          <a:solidFill>
+                            <a:srgbClr val="1D1D1F"/>
+                          </a:solidFill>
+                          <a:latin typeface="Pretendard" pitchFamily="34" charset="0"/>
+                          <a:ea typeface="Pretendard" pitchFamily="34" charset="-122"/>
+                          <a:cs typeface="Pretendard" pitchFamily="34" charset="-120"/>
+                        </a:rPr>
                         <a:t>"룩북 시안 만들어줘"</a:t>
                       </a:r>
-                      <a:endParaRPr lang="en-US" sz="1100" dirty="0">
+                      <a:endParaRPr lang="en-US" sz="1150" dirty="0">
                         <a:latin typeface="Pretendard" charset="0"/>
                         <a:ea typeface="Pretendard" charset="0"/>
                         <a:cs typeface="Pretendard" charset="0"/>
@@ -7263,6 +7606,8 @@
                     </a:solidFill>
                   </a:tcPr>
                 </a:tc>
+              </a:tr>
+              <a:tr h="438912">
                 <a:tc>
                   <a:txBody>
                     <a:bodyPr/>
@@ -7272,87 +7617,17 @@
                         <a:buNone/>
                       </a:pPr>
                       <a:r>
-                        <a:rPr lang="en-US" sz="1100" dirty="0">
+                        <a:rPr lang="en-US" sz="1150" dirty="0">
                           <a:solidFill>
-                            <a:srgbClr val="55555A"/>
-                          </a:solidFill>
-                          <a:latin typeface="Pretendard" pitchFamily="34" charset="0"/>
-                          <a:ea typeface="Pretendard" pitchFamily="34" charset="-122"/>
-                          <a:cs typeface="Pretendard" pitchFamily="34" charset="-120"/>
-                        </a:rPr>
-                        <a:t>후보</a:t>
-                      </a:r>
-                      <a:endParaRPr lang="en-US" sz="1100" dirty="0">
-                        <a:latin typeface="Pretendard" charset="0"/>
-                        <a:ea typeface="Pretendard" charset="0"/>
-                        <a:cs typeface="Pretendard" charset="0"/>
-                      </a:endParaRPr>
-                    </a:p>
-                  </a:txBody>
-                  <a:tcPr marL="101600" marR="101600" marT="38100" marB="38100" anchor="ctr">
-                    <a:lnL w="6350" cap="flat" cmpd="sng" algn="ctr">
-                      <a:solidFill>
-                        <a:srgbClr val="E5E7EB"/>
-                      </a:solidFill>
-                      <a:prstDash val="solid"/>
-                      <a:round/>
-                      <a:headEnd type="none" w="med" len="med"/>
-                      <a:tailEnd type="none" w="med" len="med"/>
-                    </a:lnL>
-                    <a:lnR w="6350" cap="flat" cmpd="sng" algn="ctr">
-                      <a:solidFill>
-                        <a:srgbClr val="E5E7EB"/>
-                      </a:solidFill>
-                      <a:prstDash val="solid"/>
-                      <a:round/>
-                      <a:headEnd type="none" w="med" len="med"/>
-                      <a:tailEnd type="none" w="med" len="med"/>
-                    </a:lnR>
-                    <a:lnT w="6350" cap="flat" cmpd="sng" algn="ctr">
-                      <a:solidFill>
-                        <a:srgbClr val="E5E7EB"/>
-                      </a:solidFill>
-                      <a:prstDash val="solid"/>
-                      <a:round/>
-                      <a:headEnd type="none" w="med" len="med"/>
-                      <a:tailEnd type="none" w="med" len="med"/>
-                    </a:lnT>
-                    <a:lnB w="6350" cap="flat" cmpd="sng" algn="ctr">
-                      <a:solidFill>
-                        <a:srgbClr val="E5E7EB"/>
-                      </a:solidFill>
-                      <a:prstDash val="solid"/>
-                      <a:round/>
-                      <a:headEnd type="none" w="med" len="med"/>
-                      <a:tailEnd type="none" w="med" len="med"/>
-                    </a:lnB>
-                    <a:solidFill>
-                      <a:srgbClr val="F5F5F7"/>
-                    </a:solidFill>
-                  </a:tcPr>
-                </a:tc>
-              </a:tr>
-              <a:tr h="475488">
-                <a:tc>
-                  <a:txBody>
-                    <a:bodyPr/>
-                    <a:lstStyle/>
-                    <a:p>
-                      <a:pPr indent="0" marL="0">
-                        <a:buNone/>
-                      </a:pPr>
-                      <a:r>
-                        <a:rPr lang="en-US" sz="1200" dirty="0">
-                          <a:solidFill>
-                            <a:srgbClr val="1D1D1F"/>
+                            <a:srgbClr val="6E6E73"/>
                           </a:solidFill>
                           <a:latin typeface="Pretendard SemiBold" pitchFamily="34" charset="0"/>
                           <a:ea typeface="Pretendard SemiBold" pitchFamily="34" charset="-122"/>
                           <a:cs typeface="Pretendard SemiBold" pitchFamily="34" charset="-120"/>
                         </a:rPr>
-                        <a:t>룩북 초안 제작</a:t>
+                        <a:t>Figma 제작</a:t>
                       </a:r>
-                      <a:endParaRPr lang="en-US" sz="1200" dirty="0">
+                      <a:endParaRPr lang="en-US" sz="1150" dirty="0">
                         <a:latin typeface="Pretendard SemiBold" charset="0"/>
                         <a:ea typeface="Pretendard SemiBold" charset="0"/>
                         <a:cs typeface="Pretendard SemiBold" charset="0"/>
@@ -7410,9 +7685,9 @@
                         <a:buNone/>
                       </a:pPr>
                       <a:r>
-                        <a:rPr lang="en-US" sz="1100" dirty="0">
+                        <a:rPr lang="en-US" sz="1150" dirty="0">
                           <a:solidFill>
-                            <a:srgbClr val="55555A"/>
+                            <a:srgbClr val="1D1D1F"/>
                           </a:solidFill>
                           <a:latin typeface="Pretendard" pitchFamily="34" charset="0"/>
                           <a:ea typeface="Pretendard" pitchFamily="34" charset="-122"/>
@@ -7420,7 +7695,7 @@
                         </a:rPr>
                         <a:t>"초안 만들어줘"</a:t>
                       </a:r>
-                      <a:endParaRPr lang="en-US" sz="1100" dirty="0">
+                      <a:endParaRPr lang="en-US" sz="1150" dirty="0">
                         <a:latin typeface="Pretendard" charset="0"/>
                         <a:ea typeface="Pretendard" charset="0"/>
                         <a:cs typeface="Pretendard" charset="0"/>
@@ -7537,6 +7812,8 @@
                     </a:solidFill>
                   </a:tcPr>
                 </a:tc>
+              </a:tr>
+              <a:tr h="438912">
                 <a:tc>
                   <a:txBody>
                     <a:bodyPr/>
@@ -7546,87 +7823,17 @@
                         <a:buNone/>
                       </a:pPr>
                       <a:r>
-                        <a:rPr lang="en-US" sz="1100" dirty="0">
+                        <a:rPr lang="en-US" sz="1150" dirty="0">
                           <a:solidFill>
-                            <a:srgbClr val="55555A"/>
-                          </a:solidFill>
-                          <a:latin typeface="Pretendard" pitchFamily="34" charset="0"/>
-                          <a:ea typeface="Pretendard" pitchFamily="34" charset="-122"/>
-                          <a:cs typeface="Pretendard" pitchFamily="34" charset="-120"/>
-                        </a:rPr>
-                        <a:t>—</a:t>
-                      </a:r>
-                      <a:endParaRPr lang="en-US" sz="1100" dirty="0">
-                        <a:latin typeface="Pretendard" charset="0"/>
-                        <a:ea typeface="Pretendard" charset="0"/>
-                        <a:cs typeface="Pretendard" charset="0"/>
-                      </a:endParaRPr>
-                    </a:p>
-                  </a:txBody>
-                  <a:tcPr marL="101600" marR="101600" marT="38100" marB="38100" anchor="ctr">
-                    <a:lnL w="6350" cap="flat" cmpd="sng" algn="ctr">
-                      <a:solidFill>
-                        <a:srgbClr val="E5E7EB"/>
-                      </a:solidFill>
-                      <a:prstDash val="solid"/>
-                      <a:round/>
-                      <a:headEnd type="none" w="med" len="med"/>
-                      <a:tailEnd type="none" w="med" len="med"/>
-                    </a:lnL>
-                    <a:lnR w="6350" cap="flat" cmpd="sng" algn="ctr">
-                      <a:solidFill>
-                        <a:srgbClr val="E5E7EB"/>
-                      </a:solidFill>
-                      <a:prstDash val="solid"/>
-                      <a:round/>
-                      <a:headEnd type="none" w="med" len="med"/>
-                      <a:tailEnd type="none" w="med" len="med"/>
-                    </a:lnR>
-                    <a:lnT w="6350" cap="flat" cmpd="sng" algn="ctr">
-                      <a:solidFill>
-                        <a:srgbClr val="E5E7EB"/>
-                      </a:solidFill>
-                      <a:prstDash val="solid"/>
-                      <a:round/>
-                      <a:headEnd type="none" w="med" len="med"/>
-                      <a:tailEnd type="none" w="med" len="med"/>
-                    </a:lnT>
-                    <a:lnB w="6350" cap="flat" cmpd="sng" algn="ctr">
-                      <a:solidFill>
-                        <a:srgbClr val="E5E7EB"/>
-                      </a:solidFill>
-                      <a:prstDash val="solid"/>
-                      <a:round/>
-                      <a:headEnd type="none" w="med" len="med"/>
-                      <a:tailEnd type="none" w="med" len="med"/>
-                    </a:lnB>
-                    <a:solidFill>
-                      <a:srgbClr val="FFFFFF"/>
-                    </a:solidFill>
-                  </a:tcPr>
-                </a:tc>
-              </a:tr>
-              <a:tr h="475488">
-                <a:tc>
-                  <a:txBody>
-                    <a:bodyPr/>
-                    <a:lstStyle/>
-                    <a:p>
-                      <a:pPr indent="0" marL="0">
-                        <a:buNone/>
-                      </a:pPr>
-                      <a:r>
-                        <a:rPr lang="en-US" sz="1200" dirty="0">
-                          <a:solidFill>
-                            <a:srgbClr val="1D1D1F"/>
+                            <a:srgbClr val="6E6E73"/>
                           </a:solidFill>
                           <a:latin typeface="Pretendard SemiBold" pitchFamily="34" charset="0"/>
                           <a:ea typeface="Pretendard SemiBold" pitchFamily="34" charset="-122"/>
                           <a:cs typeface="Pretendard SemiBold" pitchFamily="34" charset="-120"/>
                         </a:rPr>
-                        <a:t>CdBd 콘텐츠 등록</a:t>
+                        <a:t>Figma 제작</a:t>
                       </a:r>
-                      <a:endParaRPr lang="en-US" sz="1200" dirty="0">
+                      <a:endParaRPr lang="en-US" sz="1150" dirty="0">
                         <a:latin typeface="Pretendard SemiBold" charset="0"/>
                         <a:ea typeface="Pretendard SemiBold" charset="0"/>
                         <a:cs typeface="Pretendard SemiBold" charset="0"/>
@@ -7684,17 +7891,17 @@
                         <a:buNone/>
                       </a:pPr>
                       <a:r>
-                        <a:rPr lang="en-US" sz="1100" dirty="0">
+                        <a:rPr lang="en-US" sz="1150" dirty="0">
                           <a:solidFill>
-                            <a:srgbClr val="55555A"/>
+                            <a:srgbClr val="1D1D1F"/>
                           </a:solidFill>
                           <a:latin typeface="Pretendard" pitchFamily="34" charset="0"/>
                           <a:ea typeface="Pretendard" pitchFamily="34" charset="-122"/>
                           <a:cs typeface="Pretendard" pitchFamily="34" charset="-120"/>
                         </a:rPr>
-                        <a:t>"CdBd에 올려줘"</a:t>
+                        <a:t>"화보 배치해줘"</a:t>
                       </a:r>
-                      <a:endParaRPr lang="en-US" sz="1100" dirty="0">
+                      <a:endParaRPr lang="en-US" sz="1150" dirty="0">
                         <a:latin typeface="Pretendard" charset="0"/>
                         <a:ea typeface="Pretendard" charset="0"/>
                         <a:cs typeface="Pretendard" charset="0"/>
@@ -7740,280 +7947,6 @@
                     </a:lnB>
                     <a:solidFill>
                       <a:srgbClr val="F5F5F7"/>
-                    </a:solidFill>
-                  </a:tcPr>
-                </a:tc>
-                <a:tc>
-                  <a:txBody>
-                    <a:bodyPr/>
-                    <a:lstStyle/>
-                    <a:p>
-                      <a:pPr indent="0" marL="0">
-                        <a:buNone/>
-                      </a:pPr>
-                      <a:r>
-                        <a:rPr lang="en-US" sz="1100" dirty="0">
-                          <a:solidFill>
-                            <a:srgbClr val="55555A"/>
-                          </a:solidFill>
-                          <a:latin typeface="Pretendard" pitchFamily="34" charset="0"/>
-                          <a:ea typeface="Pretendard" pitchFamily="34" charset="-122"/>
-                          <a:cs typeface="Pretendard" pitchFamily="34" charset="-120"/>
-                        </a:rPr>
-                        <a:t>룩북/1. 제작 프로세스/1-4. CdBd 콘텐츠.md §등록 워크플로우</a:t>
-                      </a:r>
-                      <a:endParaRPr lang="en-US" sz="1100" dirty="0">
-                        <a:latin typeface="Pretendard" charset="0"/>
-                        <a:ea typeface="Pretendard" charset="0"/>
-                        <a:cs typeface="Pretendard" charset="0"/>
-                      </a:endParaRPr>
-                    </a:p>
-                  </a:txBody>
-                  <a:tcPr marL="101600" marR="101600" marT="38100" marB="38100" anchor="ctr">
-                    <a:lnL w="6350" cap="flat" cmpd="sng" algn="ctr">
-                      <a:solidFill>
-                        <a:srgbClr val="E5E7EB"/>
-                      </a:solidFill>
-                      <a:prstDash val="solid"/>
-                      <a:round/>
-                      <a:headEnd type="none" w="med" len="med"/>
-                      <a:tailEnd type="none" w="med" len="med"/>
-                    </a:lnL>
-                    <a:lnR w="6350" cap="flat" cmpd="sng" algn="ctr">
-                      <a:solidFill>
-                        <a:srgbClr val="E5E7EB"/>
-                      </a:solidFill>
-                      <a:prstDash val="solid"/>
-                      <a:round/>
-                      <a:headEnd type="none" w="med" len="med"/>
-                      <a:tailEnd type="none" w="med" len="med"/>
-                    </a:lnR>
-                    <a:lnT w="6350" cap="flat" cmpd="sng" algn="ctr">
-                      <a:solidFill>
-                        <a:srgbClr val="E5E7EB"/>
-                      </a:solidFill>
-                      <a:prstDash val="solid"/>
-                      <a:round/>
-                      <a:headEnd type="none" w="med" len="med"/>
-                      <a:tailEnd type="none" w="med" len="med"/>
-                    </a:lnT>
-                    <a:lnB w="6350" cap="flat" cmpd="sng" algn="ctr">
-                      <a:solidFill>
-                        <a:srgbClr val="E5E7EB"/>
-                      </a:solidFill>
-                      <a:prstDash val="solid"/>
-                      <a:round/>
-                      <a:headEnd type="none" w="med" len="med"/>
-                      <a:tailEnd type="none" w="med" len="med"/>
-                    </a:lnB>
-                    <a:solidFill>
-                      <a:srgbClr val="F5F5F7"/>
-                    </a:solidFill>
-                  </a:tcPr>
-                </a:tc>
-                <a:tc>
-                  <a:txBody>
-                    <a:bodyPr/>
-                    <a:lstStyle/>
-                    <a:p>
-                      <a:pPr indent="0" marL="0">
-                        <a:buNone/>
-                      </a:pPr>
-                      <a:r>
-                        <a:rPr lang="en-US" sz="1100" dirty="0">
-                          <a:solidFill>
-                            <a:srgbClr val="55555A"/>
-                          </a:solidFill>
-                          <a:latin typeface="Pretendard" pitchFamily="34" charset="0"/>
-                          <a:ea typeface="Pretendard" pitchFamily="34" charset="-122"/>
-                          <a:cs typeface="Pretendard" pitchFamily="34" charset="-120"/>
-                        </a:rPr>
-                        <a:t>후보</a:t>
-                      </a:r>
-                      <a:endParaRPr lang="en-US" sz="1100" dirty="0">
-                        <a:latin typeface="Pretendard" charset="0"/>
-                        <a:ea typeface="Pretendard" charset="0"/>
-                        <a:cs typeface="Pretendard" charset="0"/>
-                      </a:endParaRPr>
-                    </a:p>
-                  </a:txBody>
-                  <a:tcPr marL="101600" marR="101600" marT="38100" marB="38100" anchor="ctr">
-                    <a:lnL w="6350" cap="flat" cmpd="sng" algn="ctr">
-                      <a:solidFill>
-                        <a:srgbClr val="E5E7EB"/>
-                      </a:solidFill>
-                      <a:prstDash val="solid"/>
-                      <a:round/>
-                      <a:headEnd type="none" w="med" len="med"/>
-                      <a:tailEnd type="none" w="med" len="med"/>
-                    </a:lnL>
-                    <a:lnR w="6350" cap="flat" cmpd="sng" algn="ctr">
-                      <a:solidFill>
-                        <a:srgbClr val="E5E7EB"/>
-                      </a:solidFill>
-                      <a:prstDash val="solid"/>
-                      <a:round/>
-                      <a:headEnd type="none" w="med" len="med"/>
-                      <a:tailEnd type="none" w="med" len="med"/>
-                    </a:lnR>
-                    <a:lnT w="6350" cap="flat" cmpd="sng" algn="ctr">
-                      <a:solidFill>
-                        <a:srgbClr val="E5E7EB"/>
-                      </a:solidFill>
-                      <a:prstDash val="solid"/>
-                      <a:round/>
-                      <a:headEnd type="none" w="med" len="med"/>
-                      <a:tailEnd type="none" w="med" len="med"/>
-                    </a:lnT>
-                    <a:lnB w="6350" cap="flat" cmpd="sng" algn="ctr">
-                      <a:solidFill>
-                        <a:srgbClr val="E5E7EB"/>
-                      </a:solidFill>
-                      <a:prstDash val="solid"/>
-                      <a:round/>
-                      <a:headEnd type="none" w="med" len="med"/>
-                      <a:tailEnd type="none" w="med" len="med"/>
-                    </a:lnB>
-                    <a:solidFill>
-                      <a:srgbClr val="F5F5F7"/>
-                    </a:solidFill>
-                  </a:tcPr>
-                </a:tc>
-              </a:tr>
-              <a:tr h="475488">
-                <a:tc>
-                  <a:txBody>
-                    <a:bodyPr/>
-                    <a:lstStyle/>
-                    <a:p>
-                      <a:pPr indent="0" marL="0">
-                        <a:buNone/>
-                      </a:pPr>
-                      <a:r>
-                        <a:rPr lang="en-US" sz="1200" dirty="0">
-                          <a:solidFill>
-                            <a:srgbClr val="1D1D1F"/>
-                          </a:solidFill>
-                          <a:latin typeface="Pretendard SemiBold" pitchFamily="34" charset="0"/>
-                          <a:ea typeface="Pretendard SemiBold" pitchFamily="34" charset="-122"/>
-                          <a:cs typeface="Pretendard SemiBold" pitchFamily="34" charset="-120"/>
-                        </a:rPr>
-                        <a:t>화보·상품 배치</a:t>
-                      </a:r>
-                      <a:endParaRPr lang="en-US" sz="1200" dirty="0">
-                        <a:latin typeface="Pretendard SemiBold" charset="0"/>
-                        <a:ea typeface="Pretendard SemiBold" charset="0"/>
-                        <a:cs typeface="Pretendard SemiBold" charset="0"/>
-                      </a:endParaRPr>
-                    </a:p>
-                  </a:txBody>
-                  <a:tcPr marL="101600" marR="101600" marT="38100" marB="38100" anchor="ctr">
-                    <a:lnL w="6350" cap="flat" cmpd="sng" algn="ctr">
-                      <a:solidFill>
-                        <a:srgbClr val="E5E7EB"/>
-                      </a:solidFill>
-                      <a:prstDash val="solid"/>
-                      <a:round/>
-                      <a:headEnd type="none" w="med" len="med"/>
-                      <a:tailEnd type="none" w="med" len="med"/>
-                    </a:lnL>
-                    <a:lnR w="6350" cap="flat" cmpd="sng" algn="ctr">
-                      <a:solidFill>
-                        <a:srgbClr val="E5E7EB"/>
-                      </a:solidFill>
-                      <a:prstDash val="solid"/>
-                      <a:round/>
-                      <a:headEnd type="none" w="med" len="med"/>
-                      <a:tailEnd type="none" w="med" len="med"/>
-                    </a:lnR>
-                    <a:lnT w="6350" cap="flat" cmpd="sng" algn="ctr">
-                      <a:solidFill>
-                        <a:srgbClr val="E5E7EB"/>
-                      </a:solidFill>
-                      <a:prstDash val="solid"/>
-                      <a:round/>
-                      <a:headEnd type="none" w="med" len="med"/>
-                      <a:tailEnd type="none" w="med" len="med"/>
-                    </a:lnT>
-                    <a:lnB w="6350" cap="flat" cmpd="sng" algn="ctr">
-                      <a:solidFill>
-                        <a:srgbClr val="E5E7EB"/>
-                      </a:solidFill>
-                      <a:prstDash val="solid"/>
-                      <a:round/>
-                      <a:headEnd type="none" w="med" len="med"/>
-                      <a:tailEnd type="none" w="med" len="med"/>
-                    </a:lnB>
-                    <a:solidFill>
-                      <a:srgbClr val="FFFFFF"/>
-                    </a:solidFill>
-                  </a:tcPr>
-                </a:tc>
-                <a:tc>
-                  <a:txBody>
-                    <a:bodyPr/>
-                    <a:lstStyle/>
-                    <a:p>
-                      <a:pPr indent="0" marL="0">
-                        <a:buNone/>
-                      </a:pPr>
-                      <a:r>
-                        <a:rPr lang="en-US" sz="1100" dirty="0">
-                          <a:solidFill>
-                            <a:srgbClr val="55555A"/>
-                          </a:solidFill>
-                          <a:latin typeface="Pretendard" pitchFamily="34" charset="0"/>
-                          <a:ea typeface="Pretendard" pitchFamily="34" charset="-122"/>
-                          <a:cs typeface="Pretendard" pitchFamily="34" charset="-120"/>
-                        </a:rPr>
-                        <a:t>"화보 배치해줘"</a:t>
-                      </a:r>
-                      <a:endParaRPr lang="en-US" sz="1100" dirty="0">
-                        <a:latin typeface="Pretendard" charset="0"/>
-                        <a:ea typeface="Pretendard" charset="0"/>
-                        <a:cs typeface="Pretendard" charset="0"/>
-                      </a:endParaRPr>
-                    </a:p>
-                  </a:txBody>
-                  <a:tcPr marL="101600" marR="101600" marT="38100" marB="38100" anchor="ctr">
-                    <a:lnL w="6350" cap="flat" cmpd="sng" algn="ctr">
-                      <a:solidFill>
-                        <a:srgbClr val="E5E7EB"/>
-                      </a:solidFill>
-                      <a:prstDash val="solid"/>
-                      <a:round/>
-                      <a:headEnd type="none" w="med" len="med"/>
-                      <a:tailEnd type="none" w="med" len="med"/>
-                    </a:lnL>
-                    <a:lnR w="6350" cap="flat" cmpd="sng" algn="ctr">
-                      <a:solidFill>
-                        <a:srgbClr val="E5E7EB"/>
-                      </a:solidFill>
-                      <a:prstDash val="solid"/>
-                      <a:round/>
-                      <a:headEnd type="none" w="med" len="med"/>
-                      <a:tailEnd type="none" w="med" len="med"/>
-                    </a:lnR>
-                    <a:lnT w="6350" cap="flat" cmpd="sng" algn="ctr">
-                      <a:solidFill>
-                        <a:srgbClr val="E5E7EB"/>
-                      </a:solidFill>
-                      <a:prstDash val="solid"/>
-                      <a:round/>
-                      <a:headEnd type="none" w="med" len="med"/>
-                      <a:tailEnd type="none" w="med" len="med"/>
-                    </a:lnT>
-                    <a:lnB w="6350" cap="flat" cmpd="sng" algn="ctr">
-                      <a:solidFill>
-                        <a:srgbClr val="E5E7EB"/>
-                      </a:solidFill>
-                      <a:prstDash val="solid"/>
-                      <a:round/>
-                      <a:headEnd type="none" w="med" len="med"/>
-                      <a:tailEnd type="none" w="med" len="med"/>
-                    </a:lnB>
-                    <a:solidFill>
-                      <a:srgbClr val="FFFFFF"/>
                     </a:solidFill>
                   </a:tcPr>
                 </a:tc>
@@ -8081,6 +8014,76 @@
                       <a:tailEnd type="none" w="med" len="med"/>
                     </a:lnB>
                     <a:solidFill>
+                      <a:srgbClr val="F5F5F7"/>
+                    </a:solidFill>
+                  </a:tcPr>
+                </a:tc>
+              </a:tr>
+              <a:tr h="438912">
+                <a:tc>
+                  <a:txBody>
+                    <a:bodyPr/>
+                    <a:lstStyle/>
+                    <a:p>
+                      <a:pPr indent="0" marL="0">
+                        <a:buNone/>
+                      </a:pPr>
+                      <a:r>
+                        <a:rPr lang="en-US" sz="1150" dirty="0">
+                          <a:solidFill>
+                            <a:srgbClr val="6E6E73"/>
+                          </a:solidFill>
+                          <a:latin typeface="Pretendard SemiBold" pitchFamily="34" charset="0"/>
+                          <a:ea typeface="Pretendard SemiBold" pitchFamily="34" charset="-122"/>
+                          <a:cs typeface="Pretendard SemiBold" pitchFamily="34" charset="-120"/>
+                        </a:rPr>
+                        <a:t>Figma 제작</a:t>
+                      </a:r>
+                      <a:endParaRPr lang="en-US" sz="1150" dirty="0">
+                        <a:latin typeface="Pretendard SemiBold" charset="0"/>
+                        <a:ea typeface="Pretendard SemiBold" charset="0"/>
+                        <a:cs typeface="Pretendard SemiBold" charset="0"/>
+                      </a:endParaRPr>
+                    </a:p>
+                  </a:txBody>
+                  <a:tcPr marL="101600" marR="101600" marT="38100" marB="38100" anchor="ctr">
+                    <a:lnL w="6350" cap="flat" cmpd="sng" algn="ctr">
+                      <a:solidFill>
+                        <a:srgbClr val="E5E7EB"/>
+                      </a:solidFill>
+                      <a:prstDash val="solid"/>
+                      <a:round/>
+                      <a:headEnd type="none" w="med" len="med"/>
+                      <a:tailEnd type="none" w="med" len="med"/>
+                    </a:lnL>
+                    <a:lnR w="6350" cap="flat" cmpd="sng" algn="ctr">
+                      <a:solidFill>
+                        <a:srgbClr val="E5E7EB"/>
+                      </a:solidFill>
+                      <a:prstDash val="solid"/>
+                      <a:round/>
+                      <a:headEnd type="none" w="med" len="med"/>
+                      <a:tailEnd type="none" w="med" len="med"/>
+                    </a:lnR>
+                    <a:lnT w="6350" cap="flat" cmpd="sng" algn="ctr">
+                      <a:solidFill>
+                        <a:srgbClr val="E5E7EB"/>
+                      </a:solidFill>
+                      <a:prstDash val="solid"/>
+                      <a:round/>
+                      <a:headEnd type="none" w="med" len="med"/>
+                      <a:tailEnd type="none" w="med" len="med"/>
+                    </a:lnT>
+                    <a:lnB w="6350" cap="flat" cmpd="sng" algn="ctr">
+                      <a:solidFill>
+                        <a:srgbClr val="E5E7EB"/>
+                      </a:solidFill>
+                      <a:prstDash val="solid"/>
+                      <a:round/>
+                      <a:headEnd type="none" w="med" len="med"/>
+                      <a:tailEnd type="none" w="med" len="med"/>
+                    </a:lnB>
+                    <a:solidFill>
                       <a:srgbClr val="FFFFFF"/>
                     </a:solidFill>
                   </a:tcPr>
@@ -8094,17 +8097,17 @@
                         <a:buNone/>
                       </a:pPr>
                       <a:r>
-                        <a:rPr lang="en-US" sz="1100" dirty="0">
+                        <a:rPr lang="en-US" sz="1150" dirty="0">
                           <a:solidFill>
-                            <a:srgbClr val="55555A"/>
+                            <a:srgbClr val="1D1D1F"/>
                           </a:solidFill>
                           <a:latin typeface="Pretendard" pitchFamily="34" charset="0"/>
                           <a:ea typeface="Pretendard" pitchFamily="34" charset="-122"/>
                           <a:cs typeface="Pretendard" pitchFamily="34" charset="-120"/>
                         </a:rPr>
-                        <a:t>—</a:t>
+                        <a:t>"소식지 만들어줘"</a:t>
                       </a:r>
-                      <a:endParaRPr lang="en-US" sz="1100" dirty="0">
+                      <a:endParaRPr lang="en-US" sz="1150" dirty="0">
                         <a:latin typeface="Pretendard" charset="0"/>
                         <a:ea typeface="Pretendard" charset="0"/>
                         <a:cs typeface="Pretendard" charset="0"/>
@@ -8150,144 +8153,6 @@
                     </a:lnB>
                     <a:solidFill>
                       <a:srgbClr val="FFFFFF"/>
-                    </a:solidFill>
-                  </a:tcPr>
-                </a:tc>
-              </a:tr>
-              <a:tr h="475488">
-                <a:tc>
-                  <a:txBody>
-                    <a:bodyPr/>
-                    <a:lstStyle/>
-                    <a:p>
-                      <a:pPr indent="0" marL="0">
-                        <a:buNone/>
-                      </a:pPr>
-                      <a:r>
-                        <a:rPr lang="en-US" sz="1200" dirty="0">
-                          <a:solidFill>
-                            <a:srgbClr val="1D1D1F"/>
-                          </a:solidFill>
-                          <a:latin typeface="Pretendard SemiBold" pitchFamily="34" charset="0"/>
-                          <a:ea typeface="Pretendard SemiBold" pitchFamily="34" charset="-122"/>
-                          <a:cs typeface="Pretendard SemiBold" pitchFamily="34" charset="-120"/>
-                        </a:rPr>
-                        <a:t>소식지 제작</a:t>
-                      </a:r>
-                      <a:endParaRPr lang="en-US" sz="1200" dirty="0">
-                        <a:latin typeface="Pretendard SemiBold" charset="0"/>
-                        <a:ea typeface="Pretendard SemiBold" charset="0"/>
-                        <a:cs typeface="Pretendard SemiBold" charset="0"/>
-                      </a:endParaRPr>
-                    </a:p>
-                  </a:txBody>
-                  <a:tcPr marL="101600" marR="101600" marT="38100" marB="38100" anchor="ctr">
-                    <a:lnL w="6350" cap="flat" cmpd="sng" algn="ctr">
-                      <a:solidFill>
-                        <a:srgbClr val="E5E7EB"/>
-                      </a:solidFill>
-                      <a:prstDash val="solid"/>
-                      <a:round/>
-                      <a:headEnd type="none" w="med" len="med"/>
-                      <a:tailEnd type="none" w="med" len="med"/>
-                    </a:lnL>
-                    <a:lnR w="6350" cap="flat" cmpd="sng" algn="ctr">
-                      <a:solidFill>
-                        <a:srgbClr val="E5E7EB"/>
-                      </a:solidFill>
-                      <a:prstDash val="solid"/>
-                      <a:round/>
-                      <a:headEnd type="none" w="med" len="med"/>
-                      <a:tailEnd type="none" w="med" len="med"/>
-                    </a:lnR>
-                    <a:lnT w="6350" cap="flat" cmpd="sng" algn="ctr">
-                      <a:solidFill>
-                        <a:srgbClr val="E5E7EB"/>
-                      </a:solidFill>
-                      <a:prstDash val="solid"/>
-                      <a:round/>
-                      <a:headEnd type="none" w="med" len="med"/>
-                      <a:tailEnd type="none" w="med" len="med"/>
-                    </a:lnT>
-                    <a:lnB w="6350" cap="flat" cmpd="sng" algn="ctr">
-                      <a:solidFill>
-                        <a:srgbClr val="E5E7EB"/>
-                      </a:solidFill>
-                      <a:prstDash val="solid"/>
-                      <a:round/>
-                      <a:headEnd type="none" w="med" len="med"/>
-                      <a:tailEnd type="none" w="med" len="med"/>
-                    </a:lnB>
-                    <a:solidFill>
-                      <a:srgbClr val="F5F5F7"/>
-                    </a:solidFill>
-                  </a:tcPr>
-                </a:tc>
-                <a:tc>
-                  <a:txBody>
-                    <a:bodyPr/>
-                    <a:lstStyle/>
-                    <a:p>
-                      <a:pPr indent="0" marL="0">
-                        <a:buNone/>
-                      </a:pPr>
-                      <a:r>
-                        <a:rPr lang="en-US" sz="1100" dirty="0">
-                          <a:solidFill>
-                            <a:srgbClr val="55555A"/>
-                          </a:solidFill>
-                          <a:latin typeface="Pretendard" pitchFamily="34" charset="0"/>
-                          <a:ea typeface="Pretendard" pitchFamily="34" charset="-122"/>
-                          <a:cs typeface="Pretendard" pitchFamily="34" charset="-120"/>
-                        </a:rPr>
-                        <a:t>"소식지 만들어줘"</a:t>
-                      </a:r>
-                      <a:endParaRPr lang="en-US" sz="1100" dirty="0">
-                        <a:latin typeface="Pretendard" charset="0"/>
-                        <a:ea typeface="Pretendard" charset="0"/>
-                        <a:cs typeface="Pretendard" charset="0"/>
-                      </a:endParaRPr>
-                    </a:p>
-                  </a:txBody>
-                  <a:tcPr marL="101600" marR="101600" marT="38100" marB="38100" anchor="ctr">
-                    <a:lnL w="6350" cap="flat" cmpd="sng" algn="ctr">
-                      <a:solidFill>
-                        <a:srgbClr val="E5E7EB"/>
-                      </a:solidFill>
-                      <a:prstDash val="solid"/>
-                      <a:round/>
-                      <a:headEnd type="none" w="med" len="med"/>
-                      <a:tailEnd type="none" w="med" len="med"/>
-                    </a:lnL>
-                    <a:lnR w="6350" cap="flat" cmpd="sng" algn="ctr">
-                      <a:solidFill>
-                        <a:srgbClr val="E5E7EB"/>
-                      </a:solidFill>
-                      <a:prstDash val="solid"/>
-                      <a:round/>
-                      <a:headEnd type="none" w="med" len="med"/>
-                      <a:tailEnd type="none" w="med" len="med"/>
-                    </a:lnR>
-                    <a:lnT w="6350" cap="flat" cmpd="sng" algn="ctr">
-                      <a:solidFill>
-                        <a:srgbClr val="E5E7EB"/>
-                      </a:solidFill>
-                      <a:prstDash val="solid"/>
-                      <a:round/>
-                      <a:headEnd type="none" w="med" len="med"/>
-                      <a:tailEnd type="none" w="med" len="med"/>
-                    </a:lnT>
-                    <a:lnB w="6350" cap="flat" cmpd="sng" algn="ctr">
-                      <a:solidFill>
-                        <a:srgbClr val="E5E7EB"/>
-                      </a:solidFill>
-                      <a:prstDash val="solid"/>
-                      <a:round/>
-                      <a:headEnd type="none" w="med" len="med"/>
-                      <a:tailEnd type="none" w="med" len="med"/>
-                    </a:lnB>
-                    <a:solidFill>
-                      <a:srgbClr val="F5F5F7"/>
                     </a:solidFill>
                   </a:tcPr>
                 </a:tc>
@@ -8355,75 +8220,7 @@
                       <a:tailEnd type="none" w="med" len="med"/>
                     </a:lnB>
                     <a:solidFill>
-                      <a:srgbClr val="F5F5F7"/>
-                    </a:solidFill>
-                  </a:tcPr>
-                </a:tc>
-                <a:tc>
-                  <a:txBody>
-                    <a:bodyPr/>
-                    <a:lstStyle/>
-                    <a:p>
-                      <a:pPr indent="0" marL="0">
-                        <a:buNone/>
-                      </a:pPr>
-                      <a:r>
-                        <a:rPr lang="en-US" sz="1100" dirty="0">
-                          <a:solidFill>
-                            <a:srgbClr val="55555A"/>
-                          </a:solidFill>
-                          <a:latin typeface="Pretendard" pitchFamily="34" charset="0"/>
-                          <a:ea typeface="Pretendard" pitchFamily="34" charset="-122"/>
-                          <a:cs typeface="Pretendard" pitchFamily="34" charset="-120"/>
-                        </a:rPr>
-                        <a:t>—</a:t>
-                      </a:r>
-                      <a:endParaRPr lang="en-US" sz="1100" dirty="0">
-                        <a:latin typeface="Pretendard" charset="0"/>
-                        <a:ea typeface="Pretendard" charset="0"/>
-                        <a:cs typeface="Pretendard" charset="0"/>
-                      </a:endParaRPr>
-                    </a:p>
-                  </a:txBody>
-                  <a:tcPr marL="101600" marR="101600" marT="38100" marB="38100" anchor="ctr">
-                    <a:lnL w="6350" cap="flat" cmpd="sng" algn="ctr">
-                      <a:solidFill>
-                        <a:srgbClr val="E5E7EB"/>
-                      </a:solidFill>
-                      <a:prstDash val="solid"/>
-                      <a:round/>
-                      <a:headEnd type="none" w="med" len="med"/>
-                      <a:tailEnd type="none" w="med" len="med"/>
-                    </a:lnL>
-                    <a:lnR w="6350" cap="flat" cmpd="sng" algn="ctr">
-                      <a:solidFill>
-                        <a:srgbClr val="E5E7EB"/>
-                      </a:solidFill>
-                      <a:prstDash val="solid"/>
-                      <a:round/>
-                      <a:headEnd type="none" w="med" len="med"/>
-                      <a:tailEnd type="none" w="med" len="med"/>
-                    </a:lnR>
-                    <a:lnT w="6350" cap="flat" cmpd="sng" algn="ctr">
-                      <a:solidFill>
-                        <a:srgbClr val="E5E7EB"/>
-                      </a:solidFill>
-                      <a:prstDash val="solid"/>
-                      <a:round/>
-                      <a:headEnd type="none" w="med" len="med"/>
-                      <a:tailEnd type="none" w="med" len="med"/>
-                    </a:lnT>
-                    <a:lnB w="6350" cap="flat" cmpd="sng" algn="ctr">
-                      <a:solidFill>
-                        <a:srgbClr val="E5E7EB"/>
-                      </a:solidFill>
-                      <a:prstDash val="solid"/>
-                      <a:round/>
-                      <a:headEnd type="none" w="med" len="med"/>
-                      <a:tailEnd type="none" w="med" len="med"/>
-                    </a:lnB>
-                    <a:solidFill>
-                      <a:srgbClr val="F5F5F7"/>
+                      <a:srgbClr val="FFFFFF"/>
                     </a:solidFill>
                   </a:tcPr>
                 </a:tc>
@@ -8440,12 +8237,12 @@
         </p:nvSpPr>
         <p:spPr>
           <a:xfrm>
-            <a:off x="777240" y="5257800"/>
-            <a:ext cx="10637215" cy="731520"/>
+            <a:off x="777240" y="5349240"/>
+            <a:ext cx="10637215" cy="777240"/>
           </a:xfrm>
           <a:prstGeom prst="roundRect">
             <a:avLst>
-              <a:gd name="adj" fmla="val 12500"/>
+              <a:gd name="adj" fmla="val 11765"/>
             </a:avLst>
           </a:prstGeom>
           <a:solidFill>
@@ -8462,8 +8259,8 @@
         </p:nvSpPr>
         <p:spPr>
           <a:xfrm>
-            <a:off x="1051560" y="5349240"/>
-            <a:ext cx="10088575" cy="548640"/>
+            <a:off x="1051560" y="5440680"/>
+            <a:ext cx="10088575" cy="594360"/>
           </a:xfrm>
           <a:prstGeom prst="rect">
             <a:avLst/>
@@ -8482,7 +8279,7 @@
               <a:buNone/>
             </a:pPr>
             <a:r>
-              <a:rPr lang="en-US" sz="1200" dirty="0">
+              <a:rPr lang="en-US" sz="1150" dirty="0">
                 <a:solidFill>
                   <a:srgbClr val="6C4CFF"/>
                 </a:solidFill>
@@ -8490,7 +8287,7 @@
                 <a:ea typeface="Pretendard SemiBold" pitchFamily="34" charset="-122"/>
                 <a:cs typeface="Pretendard SemiBold" pitchFamily="34" charset="-120"/>
               </a:rPr>
-              <a:t>＋ 도구·규칙  </a:t>
+              <a:t>경로 가이드는 이 볼트에서 시킬 수 있는 일 전부를 담되 구분합니다.  </a:t>
             </a:r>
             <a:pPr indent="0" marL="0">
               <a:lnSpc>
@@ -8499,7 +8296,7 @@
               <a:buNone/>
             </a:pPr>
             <a:r>
-              <a:rPr lang="en-US" sz="1150" dirty="0">
+              <a:rPr lang="en-US" sz="1100" dirty="0">
                 <a:solidFill>
                   <a:srgbClr val="55555A"/>
                 </a:solidFill>
@@ -8507,9 +8304,9 @@
                 <a:ea typeface="Pretendard" pitchFamily="34" charset="-122"/>
                 <a:cs typeface="Pretendard" pitchFamily="34" charset="-120"/>
               </a:rPr>
-              <a:t>로그인 세션(gstack) · Supabase 직접 자동화 · image_library.py 헬퍼는 ‘기능’이 아니라 도구 → 파일 하단 ‘도구·규칙’ 섹션에 별도 기재.</a:t>
-            </a:r>
-            <a:endParaRPr lang="en-US" sz="1200" dirty="0"/>
+              <a:t>CdBd 기능 · Figma 제작(디자인 작업) · 도구(로그인·Supabase·image_library.py). 분류표(03장)가 센 것은 이 중 ‘CdBd 기능’만.</a:t>
+            </a:r>
+            <a:endParaRPr lang="en-US" sz="1150" dirty="0"/>
           </a:p>
         </p:txBody>
       </p:sp>

</xml_diff>

<commit_message>
vault backup: 2026-08-11 15:36:37
</commit_message>
<xml_diff>
--- a/_기능별 경로 가이드 — 실행 계획.pptx
+++ b/_기능별 경로 가이드 — 실행 계획.pptx
@@ -4796,7 +4796,7 @@
                 <a:ea typeface="Pretendard Medium" pitchFamily="34" charset="-122"/>
                 <a:cs typeface="Pretendard Medium" pitchFamily="34" charset="-120"/>
               </a:rPr>
-              <a:t>07  cdbd-design-service</a:t>
+              <a:t>07  cdbd-templates</a:t>
             </a:r>
             <a:endParaRPr lang="en-US" sz="1200" dirty="0"/>
           </a:p>
@@ -4877,7 +4877,7 @@
                 <a:ea typeface="Pretendard" pitchFamily="34" charset="-122"/>
                 <a:cs typeface="Pretendard" pitchFamily="34" charset="-120"/>
               </a:rPr>
-              <a:t>저장소 1곳(추천: cdbd-design-service)을 예로.</a:t>
+              <a:t>저장소 1곳(예: cdbd-templates)을 예로.</a:t>
             </a:r>
             <a:endParaRPr lang="en-US" sz="1500" dirty="0"/>
           </a:p>
@@ -5124,7 +5124,7 @@
                 <a:ea typeface="Pretendard" pitchFamily="34" charset="-122"/>
                 <a:cs typeface="Pretendard" pitchFamily="34" charset="-120"/>
               </a:rPr>
-              <a:t>가이드 + 볼트 대조 → 이 저장소가 실제로 다루는 CdBd 기능만 추림 (콘텐츠 등록·URL 게시·이미지 라이브러리·카드 매핑·누끼 크롭)</a:t>
+              <a:t>가이드 + 볼트 대조 → 이 저장소가 실제로 다루는 기능만 추림 (에디터 카드 자동화·카드 타입·상세페이지+어드민·시안 3안·섹션 프리셋)</a:t>
             </a:r>
             <a:endParaRPr lang="en-US" sz="1150" dirty="0"/>
           </a:p>
@@ -5800,7 +5800,7 @@
                 <a:ea typeface="Pretendard" pitchFamily="34" charset="-122"/>
                 <a:cs typeface="Pretendard" pitchFamily="34" charset="-120"/>
               </a:rPr>
-              <a:t>"이 룩북 CdBd에 올려줘" → Claude가 스스로 §등록 워크플로우 열고 7단계 수행</a:t>
+              <a:t>"이 템플릿 상세페이지 만들어줘" → Claude가 스스로 1-7. 템플릿 상세 페이지.md 열고 절차 수행</a:t>
             </a:r>
             <a:endParaRPr lang="en-US" sz="1150" dirty="0"/>
           </a:p>
@@ -5910,7 +5910,7 @@
                 <a:ea typeface="Pretendard Medium" pitchFamily="34" charset="-122"/>
                 <a:cs typeface="Pretendard Medium" pitchFamily="34" charset="-120"/>
               </a:rPr>
-              <a:t>07  cdbd-design-service</a:t>
+              <a:t>07  cdbd-templates</a:t>
             </a:r>
             <a:endParaRPr lang="en-US" sz="1200" dirty="0"/>
           </a:p>
@@ -5991,7 +5991,7 @@
                 <a:ea typeface="Pretendard" pitchFamily="34" charset="-122"/>
                 <a:cs typeface="Pretendard" pitchFamily="34" charset="-120"/>
               </a:rPr>
-              <a:t>"CdBd에 올려줘" 한마디로 달라지는 것.</a:t>
+              <a:t>"카드 자동화 해줘" 한마디로 달라지는 것.</a:t>
             </a:r>
             <a:endParaRPr lang="en-US" sz="1500" dirty="0"/>
           </a:p>
@@ -6340,7 +6340,7 @@
                 <a:ea typeface="Pretendard" pitchFamily="34" charset="-122"/>
                 <a:cs typeface="Pretendard" pitchFamily="34" charset="-120"/>
               </a:rPr>
-              <a:t>· 경로 가이드에서 바로 §등록 워크플로우로 진입</a:t>
+              <a:t>· 경로 가이드에서 바로 카드 자동화 스킬·1-6-1. CdBd 에디터.md 로 진입</a:t>
             </a:r>
             <a:endParaRPr lang="en-US" sz="1300" dirty="0"/>
           </a:p>
@@ -6360,7 +6360,7 @@
                 <a:ea typeface="Pretendard" pitchFamily="34" charset="-122"/>
                 <a:cs typeface="Pretendard" pitchFamily="34" charset="-120"/>
               </a:rPr>
-              <a:t>· 폴더 확인 → 멀티페이지 → 카드 매핑 → URL·OG → 검증 → 게시 자동 흐름</a:t>
+              <a:t>· 카드 추가·삭제·복제·순서·핀·예약·링크 자동 처리</a:t>
             </a:r>
             <a:endParaRPr lang="en-US" sz="1300" dirty="0"/>
           </a:p>
@@ -6461,7 +6461,7 @@
                 <a:ea typeface="Pretendard" pitchFamily="34" charset="-122"/>
                 <a:cs typeface="Pretendard" pitchFamily="34" charset="-120"/>
               </a:rPr>
-              <a:t>· 진단서가 지적한 ‘핵심 문서 표 경로 9개 오류’ 정정   · ‘통계·개인화·버전기록 = 볼트에 없음’이 명시돼 다음 작업 목록이 생김</a:t>
+              <a:t>· 이미 있는 스킬 5종 + 스킬 없는 기능이 한 지도로 연결   · ‘통계·개인화 = 볼트에 없음’이 명시돼 다음 작업 목록이 생김</a:t>
             </a:r>
             <a:endParaRPr lang="en-US" sz="1200" dirty="0"/>
           </a:p>
@@ -6591,7 +6591,7 @@
                 <a:ea typeface="Pretendard Medium" pitchFamily="34" charset="-122"/>
                 <a:cs typeface="Pretendard Medium" pitchFamily="34" charset="-120"/>
               </a:rPr>
-              <a:t>07  cdbd-design-service</a:t>
+              <a:t>07  cdbd-templates</a:t>
             </a:r>
             <a:endParaRPr lang="en-US" sz="1200" dirty="0"/>
           </a:p>
@@ -6672,7 +6672,7 @@
                 <a:ea typeface="Pretendard" pitchFamily="34" charset="-122"/>
                 <a:cs typeface="Pretendard" pitchFamily="34" charset="-120"/>
               </a:rPr>
-              <a:t>위치 = cdbd-design-service/_기능별 경로 가이드.md  (저장소 루트, CLAUDE.md 옆)</a:t>
+              <a:t>위치 = cdbd-templates/_기능별 경로 가이드.md  (저장소 루트, CLAUDE.md 옆)</a:t>
             </a:r>
             <a:endParaRPr lang="en-US" sz="1500" dirty="0"/>
           </a:p>
@@ -6779,11 +6779,11 @@
             <a:tbl>
               <a:tblPr/>
               <a:tblGrid>
-                <a:gridCol w="1554480"/>
-                <a:gridCol w="3108960"/>
-                <a:gridCol w="5971032"/>
+                <a:gridCol w="1417320"/>
+                <a:gridCol w="2834640"/>
+                <a:gridCol w="6382512"/>
               </a:tblGrid>
-              <a:tr h="438912">
+              <a:tr h="457200">
                 <a:tc>
                   <a:txBody>
                     <a:bodyPr/>
@@ -6989,7 +6989,7 @@
                   </a:tcPr>
                 </a:tc>
               </a:tr>
-              <a:tr h="438912">
+              <a:tr h="457200">
                 <a:tc>
                   <a:txBody>
                     <a:bodyPr/>
@@ -7075,7 +7075,7 @@
                           <a:ea typeface="Pretendard" pitchFamily="34" charset="-122"/>
                           <a:cs typeface="Pretendard" pitchFamily="34" charset="-120"/>
                         </a:rPr>
-                        <a:t>"CdBd에 올려줘" (콘텐츠 등록)</a:t>
+                        <a:t>"카드 자동화 해줘" (추가·순서·핀·예약)</a:t>
                       </a:r>
                       <a:endParaRPr lang="en-US" sz="1150" dirty="0">
                         <a:latin typeface="Pretendard" charset="0"/>
@@ -7143,7 +7143,7 @@
                           <a:ea typeface="Pretendard" pitchFamily="34" charset="-122"/>
                           <a:cs typeface="Pretendard" pitchFamily="34" charset="-120"/>
                         </a:rPr>
-                        <a:t>룩북/1. 제작 프로세스/1-4. CdBd 콘텐츠.md §등록 워크플로우</a:t>
+                        <a:t>skills/cdbd-card-automation/ · 1-6-1. CdBd 에디터.md</a:t>
                       </a:r>
                       <a:endParaRPr lang="en-US" sz="1100" dirty="0">
                         <a:latin typeface="Pretendard" charset="0"/>
@@ -7195,7 +7195,7 @@
                   </a:tcPr>
                 </a:tc>
               </a:tr>
-              <a:tr h="438912">
+              <a:tr h="457200">
                 <a:tc>
                   <a:txBody>
                     <a:bodyPr/>
@@ -7281,7 +7281,7 @@
                           <a:ea typeface="Pretendard" pitchFamily="34" charset="-122"/>
                           <a:cs typeface="Pretendard" pitchFamily="34" charset="-120"/>
                         </a:rPr>
-                        <a:t>"이미지 라이브러리에 올려줘"</a:t>
+                        <a:t>"카드 타입 골라줘"</a:t>
                       </a:r>
                       <a:endParaRPr lang="en-US" sz="1150" dirty="0">
                         <a:latin typeface="Pretendard" charset="0"/>
@@ -7349,7 +7349,7 @@
                           <a:ea typeface="Pretendard" pitchFamily="34" charset="-122"/>
                           <a:cs typeface="Pretendard" pitchFamily="34" charset="-120"/>
                         </a:rPr>
-                        <a:t>CLAUDE.md §이미지 라이브러리 (image_library.py)</a:t>
+                        <a:t>1. 작업 가이드/1-6-2. CdBd 카드 기능.md</a:t>
                       </a:r>
                       <a:endParaRPr lang="en-US" sz="1100" dirty="0">
                         <a:latin typeface="Pretendard" charset="0"/>
@@ -7401,7 +7401,213 @@
                   </a:tcPr>
                 </a:tc>
               </a:tr>
-              <a:tr h="438912">
+              <a:tr h="457200">
+                <a:tc>
+                  <a:txBody>
+                    <a:bodyPr/>
+                    <a:lstStyle/>
+                    <a:p>
+                      <a:pPr indent="0" marL="0">
+                        <a:buNone/>
+                      </a:pPr>
+                      <a:r>
+                        <a:rPr lang="en-US" sz="1150" dirty="0">
+                          <a:solidFill>
+                            <a:srgbClr val="6C4CFF"/>
+                          </a:solidFill>
+                          <a:latin typeface="Pretendard SemiBold" pitchFamily="34" charset="0"/>
+                          <a:ea typeface="Pretendard SemiBold" pitchFamily="34" charset="-122"/>
+                          <a:cs typeface="Pretendard SemiBold" pitchFamily="34" charset="-120"/>
+                        </a:rPr>
+                        <a:t>CdBd 기능</a:t>
+                      </a:r>
+                      <a:endParaRPr lang="en-US" sz="1150" dirty="0">
+                        <a:latin typeface="Pretendard SemiBold" charset="0"/>
+                        <a:ea typeface="Pretendard SemiBold" charset="0"/>
+                        <a:cs typeface="Pretendard SemiBold" charset="0"/>
+                      </a:endParaRPr>
+                    </a:p>
+                  </a:txBody>
+                  <a:tcPr marL="101600" marR="101600" marT="38100" marB="38100" anchor="ctr">
+                    <a:lnL w="6350" cap="flat" cmpd="sng" algn="ctr">
+                      <a:solidFill>
+                        <a:srgbClr val="E5E7EB"/>
+                      </a:solidFill>
+                      <a:prstDash val="solid"/>
+                      <a:round/>
+                      <a:headEnd type="none" w="med" len="med"/>
+                      <a:tailEnd type="none" w="med" len="med"/>
+                    </a:lnL>
+                    <a:lnR w="6350" cap="flat" cmpd="sng" algn="ctr">
+                      <a:solidFill>
+                        <a:srgbClr val="E5E7EB"/>
+                      </a:solidFill>
+                      <a:prstDash val="solid"/>
+                      <a:round/>
+                      <a:headEnd type="none" w="med" len="med"/>
+                      <a:tailEnd type="none" w="med" len="med"/>
+                    </a:lnR>
+                    <a:lnT w="6350" cap="flat" cmpd="sng" algn="ctr">
+                      <a:solidFill>
+                        <a:srgbClr val="E5E7EB"/>
+                      </a:solidFill>
+                      <a:prstDash val="solid"/>
+                      <a:round/>
+                      <a:headEnd type="none" w="med" len="med"/>
+                      <a:tailEnd type="none" w="med" len="med"/>
+                    </a:lnT>
+                    <a:lnB w="6350" cap="flat" cmpd="sng" algn="ctr">
+                      <a:solidFill>
+                        <a:srgbClr val="E5E7EB"/>
+                      </a:solidFill>
+                      <a:prstDash val="solid"/>
+                      <a:round/>
+                      <a:headEnd type="none" w="med" len="med"/>
+                      <a:tailEnd type="none" w="med" len="med"/>
+                    </a:lnB>
+                    <a:solidFill>
+                      <a:srgbClr val="F5F5F7"/>
+                    </a:solidFill>
+                  </a:tcPr>
+                </a:tc>
+                <a:tc>
+                  <a:txBody>
+                    <a:bodyPr/>
+                    <a:lstStyle/>
+                    <a:p>
+                      <a:pPr indent="0" marL="0">
+                        <a:buNone/>
+                      </a:pPr>
+                      <a:r>
+                        <a:rPr lang="en-US" sz="1150" dirty="0">
+                          <a:solidFill>
+                            <a:srgbClr val="1D1D1F"/>
+                          </a:solidFill>
+                          <a:latin typeface="Pretendard" pitchFamily="34" charset="0"/>
+                          <a:ea typeface="Pretendard" pitchFamily="34" charset="-122"/>
+                          <a:cs typeface="Pretendard" pitchFamily="34" charset="-120"/>
+                        </a:rPr>
+                        <a:t>"상세페이지·어드민 등록해줘"</a:t>
+                      </a:r>
+                      <a:endParaRPr lang="en-US" sz="1150" dirty="0">
+                        <a:latin typeface="Pretendard" charset="0"/>
+                        <a:ea typeface="Pretendard" charset="0"/>
+                        <a:cs typeface="Pretendard" charset="0"/>
+                      </a:endParaRPr>
+                    </a:p>
+                  </a:txBody>
+                  <a:tcPr marL="101600" marR="101600" marT="38100" marB="38100" anchor="ctr">
+                    <a:lnL w="6350" cap="flat" cmpd="sng" algn="ctr">
+                      <a:solidFill>
+                        <a:srgbClr val="E5E7EB"/>
+                      </a:solidFill>
+                      <a:prstDash val="solid"/>
+                      <a:round/>
+                      <a:headEnd type="none" w="med" len="med"/>
+                      <a:tailEnd type="none" w="med" len="med"/>
+                    </a:lnL>
+                    <a:lnR w="6350" cap="flat" cmpd="sng" algn="ctr">
+                      <a:solidFill>
+                        <a:srgbClr val="E5E7EB"/>
+                      </a:solidFill>
+                      <a:prstDash val="solid"/>
+                      <a:round/>
+                      <a:headEnd type="none" w="med" len="med"/>
+                      <a:tailEnd type="none" w="med" len="med"/>
+                    </a:lnR>
+                    <a:lnT w="6350" cap="flat" cmpd="sng" algn="ctr">
+                      <a:solidFill>
+                        <a:srgbClr val="E5E7EB"/>
+                      </a:solidFill>
+                      <a:prstDash val="solid"/>
+                      <a:round/>
+                      <a:headEnd type="none" w="med" len="med"/>
+                      <a:tailEnd type="none" w="med" len="med"/>
+                    </a:lnT>
+                    <a:lnB w="6350" cap="flat" cmpd="sng" algn="ctr">
+                      <a:solidFill>
+                        <a:srgbClr val="E5E7EB"/>
+                      </a:solidFill>
+                      <a:prstDash val="solid"/>
+                      <a:round/>
+                      <a:headEnd type="none" w="med" len="med"/>
+                      <a:tailEnd type="none" w="med" len="med"/>
+                    </a:lnB>
+                    <a:solidFill>
+                      <a:srgbClr val="F5F5F7"/>
+                    </a:solidFill>
+                  </a:tcPr>
+                </a:tc>
+                <a:tc>
+                  <a:txBody>
+                    <a:bodyPr/>
+                    <a:lstStyle/>
+                    <a:p>
+                      <a:pPr indent="0" marL="0">
+                        <a:buNone/>
+                      </a:pPr>
+                      <a:r>
+                        <a:rPr lang="en-US" sz="1100" dirty="0">
+                          <a:solidFill>
+                            <a:srgbClr val="55555A"/>
+                          </a:solidFill>
+                          <a:latin typeface="Pretendard" pitchFamily="34" charset="0"/>
+                          <a:ea typeface="Pretendard" pitchFamily="34" charset="-122"/>
+                          <a:cs typeface="Pretendard" pitchFamily="34" charset="-120"/>
+                        </a:rPr>
+                        <a:t>1. 작업 가이드/1-7. 템플릿 상세 페이지.md</a:t>
+                      </a:r>
+                      <a:endParaRPr lang="en-US" sz="1100" dirty="0">
+                        <a:latin typeface="Pretendard" charset="0"/>
+                        <a:ea typeface="Pretendard" charset="0"/>
+                        <a:cs typeface="Pretendard" charset="0"/>
+                      </a:endParaRPr>
+                    </a:p>
+                  </a:txBody>
+                  <a:tcPr marL="101600" marR="101600" marT="38100" marB="38100" anchor="ctr">
+                    <a:lnL w="6350" cap="flat" cmpd="sng" algn="ctr">
+                      <a:solidFill>
+                        <a:srgbClr val="E5E7EB"/>
+                      </a:solidFill>
+                      <a:prstDash val="solid"/>
+                      <a:round/>
+                      <a:headEnd type="none" w="med" len="med"/>
+                      <a:tailEnd type="none" w="med" len="med"/>
+                    </a:lnL>
+                    <a:lnR w="6350" cap="flat" cmpd="sng" algn="ctr">
+                      <a:solidFill>
+                        <a:srgbClr val="E5E7EB"/>
+                      </a:solidFill>
+                      <a:prstDash val="solid"/>
+                      <a:round/>
+                      <a:headEnd type="none" w="med" len="med"/>
+                      <a:tailEnd type="none" w="med" len="med"/>
+                    </a:lnR>
+                    <a:lnT w="6350" cap="flat" cmpd="sng" algn="ctr">
+                      <a:solidFill>
+                        <a:srgbClr val="E5E7EB"/>
+                      </a:solidFill>
+                      <a:prstDash val="solid"/>
+                      <a:round/>
+                      <a:headEnd type="none" w="med" len="med"/>
+                      <a:tailEnd type="none" w="med" len="med"/>
+                    </a:lnT>
+                    <a:lnB w="6350" cap="flat" cmpd="sng" algn="ctr">
+                      <a:solidFill>
+                        <a:srgbClr val="E5E7EB"/>
+                      </a:solidFill>
+                      <a:prstDash val="solid"/>
+                      <a:round/>
+                      <a:headEnd type="none" w="med" len="med"/>
+                      <a:tailEnd type="none" w="med" len="med"/>
+                    </a:lnB>
+                    <a:solidFill>
+                      <a:srgbClr val="F5F5F7"/>
+                    </a:solidFill>
+                  </a:tcPr>
+                </a:tc>
+              </a:tr>
+              <a:tr h="457200">
                 <a:tc>
                   <a:txBody>
                     <a:bodyPr/>
@@ -7466,7 +7672,7 @@
                       <a:tailEnd type="none" w="med" len="med"/>
                     </a:lnB>
                     <a:solidFill>
-                      <a:srgbClr val="F5F5F7"/>
+                      <a:srgbClr val="FFFFFF"/>
                     </a:solidFill>
                   </a:tcPr>
                 </a:tc>
@@ -7487,7 +7693,7 @@
                           <a:ea typeface="Pretendard" pitchFamily="34" charset="-122"/>
                           <a:cs typeface="Pretendard" pitchFamily="34" charset="-120"/>
                         </a:rPr>
-                        <a:t>"룩북 시안 만들어줘"</a:t>
+                        <a:t>"시안 3안 만들어줘"</a:t>
                       </a:r>
                       <a:endParaRPr lang="en-US" sz="1150" dirty="0">
                         <a:latin typeface="Pretendard" charset="0"/>
@@ -7534,7 +7740,7 @@
                       <a:tailEnd type="none" w="med" len="med"/>
                     </a:lnB>
                     <a:solidFill>
-                      <a:srgbClr val="F5F5F7"/>
+                      <a:srgbClr val="FFFFFF"/>
                     </a:solidFill>
                   </a:tcPr>
                 </a:tc>
@@ -7555,7 +7761,7 @@
                           <a:ea typeface="Pretendard" pitchFamily="34" charset="-122"/>
                           <a:cs typeface="Pretendard" pitchFamily="34" charset="-120"/>
                         </a:rPr>
-                        <a:t>룩북/1. 제작 프로세스/1-2. 시안.md §제작 단계 8</a:t>
+                        <a:t>skills/draft/ (에이전트 D1~D5)</a:t>
                       </a:r>
                       <a:endParaRPr lang="en-US" sz="1100" dirty="0">
                         <a:latin typeface="Pretendard" charset="0"/>
@@ -7602,12 +7808,12 @@
                       <a:tailEnd type="none" w="med" len="med"/>
                     </a:lnB>
                     <a:solidFill>
-                      <a:srgbClr val="F5F5F7"/>
+                      <a:srgbClr val="FFFFFF"/>
                     </a:solidFill>
                   </a:tcPr>
                 </a:tc>
               </a:tr>
-              <a:tr h="438912">
+              <a:tr h="457200">
                 <a:tc>
                   <a:txBody>
                     <a:bodyPr/>
@@ -7672,7 +7878,7 @@
                       <a:tailEnd type="none" w="med" len="med"/>
                     </a:lnB>
                     <a:solidFill>
-                      <a:srgbClr val="FFFFFF"/>
+                      <a:srgbClr val="F5F5F7"/>
                     </a:solidFill>
                   </a:tcPr>
                 </a:tc>
@@ -7693,7 +7899,7 @@
                           <a:ea typeface="Pretendard" pitchFamily="34" charset="-122"/>
                           <a:cs typeface="Pretendard" pitchFamily="34" charset="-120"/>
                         </a:rPr>
-                        <a:t>"초안 만들어줘"</a:t>
+                        <a:t>"섹션 프리셋 조립해줘"</a:t>
                       </a:r>
                       <a:endParaRPr lang="en-US" sz="1150" dirty="0">
                         <a:latin typeface="Pretendard" charset="0"/>
@@ -7740,7 +7946,7 @@
                       <a:tailEnd type="none" w="med" len="med"/>
                     </a:lnB>
                     <a:solidFill>
-                      <a:srgbClr val="FFFFFF"/>
+                      <a:srgbClr val="F5F5F7"/>
                     </a:solidFill>
                   </a:tcPr>
                 </a:tc>
@@ -7761,7 +7967,7 @@
                           <a:ea typeface="Pretendard" pitchFamily="34" charset="-122"/>
                           <a:cs typeface="Pretendard" pitchFamily="34" charset="-120"/>
                         </a:rPr>
-                        <a:t>룩북/1. 제작 프로세스/1-3. 초안.md</a:t>
+                        <a:t>1. 작업 가이드/1-8. 섹션 프리셋 라이브러리.md</a:t>
                       </a:r>
                       <a:endParaRPr lang="en-US" sz="1100" dirty="0">
                         <a:latin typeface="Pretendard" charset="0"/>
@@ -7808,12 +8014,12 @@
                       <a:tailEnd type="none" w="med" len="med"/>
                     </a:lnB>
                     <a:solidFill>
-                      <a:srgbClr val="FFFFFF"/>
+                      <a:srgbClr val="F5F5F7"/>
                     </a:solidFill>
                   </a:tcPr>
                 </a:tc>
               </a:tr>
-              <a:tr h="438912">
+              <a:tr h="457200">
                 <a:tc>
                   <a:txBody>
                     <a:bodyPr/>
@@ -7878,212 +8084,6 @@
                       <a:tailEnd type="none" w="med" len="med"/>
                     </a:lnB>
                     <a:solidFill>
-                      <a:srgbClr val="F5F5F7"/>
-                    </a:solidFill>
-                  </a:tcPr>
-                </a:tc>
-                <a:tc>
-                  <a:txBody>
-                    <a:bodyPr/>
-                    <a:lstStyle/>
-                    <a:p>
-                      <a:pPr indent="0" marL="0">
-                        <a:buNone/>
-                      </a:pPr>
-                      <a:r>
-                        <a:rPr lang="en-US" sz="1150" dirty="0">
-                          <a:solidFill>
-                            <a:srgbClr val="1D1D1F"/>
-                          </a:solidFill>
-                          <a:latin typeface="Pretendard" pitchFamily="34" charset="0"/>
-                          <a:ea typeface="Pretendard" pitchFamily="34" charset="-122"/>
-                          <a:cs typeface="Pretendard" pitchFamily="34" charset="-120"/>
-                        </a:rPr>
-                        <a:t>"화보 배치해줘"</a:t>
-                      </a:r>
-                      <a:endParaRPr lang="en-US" sz="1150" dirty="0">
-                        <a:latin typeface="Pretendard" charset="0"/>
-                        <a:ea typeface="Pretendard" charset="0"/>
-                        <a:cs typeface="Pretendard" charset="0"/>
-                      </a:endParaRPr>
-                    </a:p>
-                  </a:txBody>
-                  <a:tcPr marL="101600" marR="101600" marT="38100" marB="38100" anchor="ctr">
-                    <a:lnL w="6350" cap="flat" cmpd="sng" algn="ctr">
-                      <a:solidFill>
-                        <a:srgbClr val="E5E7EB"/>
-                      </a:solidFill>
-                      <a:prstDash val="solid"/>
-                      <a:round/>
-                      <a:headEnd type="none" w="med" len="med"/>
-                      <a:tailEnd type="none" w="med" len="med"/>
-                    </a:lnL>
-                    <a:lnR w="6350" cap="flat" cmpd="sng" algn="ctr">
-                      <a:solidFill>
-                        <a:srgbClr val="E5E7EB"/>
-                      </a:solidFill>
-                      <a:prstDash val="solid"/>
-                      <a:round/>
-                      <a:headEnd type="none" w="med" len="med"/>
-                      <a:tailEnd type="none" w="med" len="med"/>
-                    </a:lnR>
-                    <a:lnT w="6350" cap="flat" cmpd="sng" algn="ctr">
-                      <a:solidFill>
-                        <a:srgbClr val="E5E7EB"/>
-                      </a:solidFill>
-                      <a:prstDash val="solid"/>
-                      <a:round/>
-                      <a:headEnd type="none" w="med" len="med"/>
-                      <a:tailEnd type="none" w="med" len="med"/>
-                    </a:lnT>
-                    <a:lnB w="6350" cap="flat" cmpd="sng" algn="ctr">
-                      <a:solidFill>
-                        <a:srgbClr val="E5E7EB"/>
-                      </a:solidFill>
-                      <a:prstDash val="solid"/>
-                      <a:round/>
-                      <a:headEnd type="none" w="med" len="med"/>
-                      <a:tailEnd type="none" w="med" len="med"/>
-                    </a:lnB>
-                    <a:solidFill>
-                      <a:srgbClr val="F5F5F7"/>
-                    </a:solidFill>
-                  </a:tcPr>
-                </a:tc>
-                <a:tc>
-                  <a:txBody>
-                    <a:bodyPr/>
-                    <a:lstStyle/>
-                    <a:p>
-                      <a:pPr indent="0" marL="0">
-                        <a:buNone/>
-                      </a:pPr>
-                      <a:r>
-                        <a:rPr lang="en-US" sz="1100" dirty="0">
-                          <a:solidFill>
-                            <a:srgbClr val="55555A"/>
-                          </a:solidFill>
-                          <a:latin typeface="Pretendard" pitchFamily="34" charset="0"/>
-                          <a:ea typeface="Pretendard" pitchFamily="34" charset="-122"/>
-                          <a:cs typeface="Pretendard" pitchFamily="34" charset="-120"/>
-                        </a:rPr>
-                        <a:t>룩북/2. 디자인 가이드/2-4. 화보·상품.md</a:t>
-                      </a:r>
-                      <a:endParaRPr lang="en-US" sz="1100" dirty="0">
-                        <a:latin typeface="Pretendard" charset="0"/>
-                        <a:ea typeface="Pretendard" charset="0"/>
-                        <a:cs typeface="Pretendard" charset="0"/>
-                      </a:endParaRPr>
-                    </a:p>
-                  </a:txBody>
-                  <a:tcPr marL="101600" marR="101600" marT="38100" marB="38100" anchor="ctr">
-                    <a:lnL w="6350" cap="flat" cmpd="sng" algn="ctr">
-                      <a:solidFill>
-                        <a:srgbClr val="E5E7EB"/>
-                      </a:solidFill>
-                      <a:prstDash val="solid"/>
-                      <a:round/>
-                      <a:headEnd type="none" w="med" len="med"/>
-                      <a:tailEnd type="none" w="med" len="med"/>
-                    </a:lnL>
-                    <a:lnR w="6350" cap="flat" cmpd="sng" algn="ctr">
-                      <a:solidFill>
-                        <a:srgbClr val="E5E7EB"/>
-                      </a:solidFill>
-                      <a:prstDash val="solid"/>
-                      <a:round/>
-                      <a:headEnd type="none" w="med" len="med"/>
-                      <a:tailEnd type="none" w="med" len="med"/>
-                    </a:lnR>
-                    <a:lnT w="6350" cap="flat" cmpd="sng" algn="ctr">
-                      <a:solidFill>
-                        <a:srgbClr val="E5E7EB"/>
-                      </a:solidFill>
-                      <a:prstDash val="solid"/>
-                      <a:round/>
-                      <a:headEnd type="none" w="med" len="med"/>
-                      <a:tailEnd type="none" w="med" len="med"/>
-                    </a:lnT>
-                    <a:lnB w="6350" cap="flat" cmpd="sng" algn="ctr">
-                      <a:solidFill>
-                        <a:srgbClr val="E5E7EB"/>
-                      </a:solidFill>
-                      <a:prstDash val="solid"/>
-                      <a:round/>
-                      <a:headEnd type="none" w="med" len="med"/>
-                      <a:tailEnd type="none" w="med" len="med"/>
-                    </a:lnB>
-                    <a:solidFill>
-                      <a:srgbClr val="F5F5F7"/>
-                    </a:solidFill>
-                  </a:tcPr>
-                </a:tc>
-              </a:tr>
-              <a:tr h="438912">
-                <a:tc>
-                  <a:txBody>
-                    <a:bodyPr/>
-                    <a:lstStyle/>
-                    <a:p>
-                      <a:pPr indent="0" marL="0">
-                        <a:buNone/>
-                      </a:pPr>
-                      <a:r>
-                        <a:rPr lang="en-US" sz="1150" dirty="0">
-                          <a:solidFill>
-                            <a:srgbClr val="6E6E73"/>
-                          </a:solidFill>
-                          <a:latin typeface="Pretendard SemiBold" pitchFamily="34" charset="0"/>
-                          <a:ea typeface="Pretendard SemiBold" pitchFamily="34" charset="-122"/>
-                          <a:cs typeface="Pretendard SemiBold" pitchFamily="34" charset="-120"/>
-                        </a:rPr>
-                        <a:t>Figma 제작</a:t>
-                      </a:r>
-                      <a:endParaRPr lang="en-US" sz="1150" dirty="0">
-                        <a:latin typeface="Pretendard SemiBold" charset="0"/>
-                        <a:ea typeface="Pretendard SemiBold" charset="0"/>
-                        <a:cs typeface="Pretendard SemiBold" charset="0"/>
-                      </a:endParaRPr>
-                    </a:p>
-                  </a:txBody>
-                  <a:tcPr marL="101600" marR="101600" marT="38100" marB="38100" anchor="ctr">
-                    <a:lnL w="6350" cap="flat" cmpd="sng" algn="ctr">
-                      <a:solidFill>
-                        <a:srgbClr val="E5E7EB"/>
-                      </a:solidFill>
-                      <a:prstDash val="solid"/>
-                      <a:round/>
-                      <a:headEnd type="none" w="med" len="med"/>
-                      <a:tailEnd type="none" w="med" len="med"/>
-                    </a:lnL>
-                    <a:lnR w="6350" cap="flat" cmpd="sng" algn="ctr">
-                      <a:solidFill>
-                        <a:srgbClr val="E5E7EB"/>
-                      </a:solidFill>
-                      <a:prstDash val="solid"/>
-                      <a:round/>
-                      <a:headEnd type="none" w="med" len="med"/>
-                      <a:tailEnd type="none" w="med" len="med"/>
-                    </a:lnR>
-                    <a:lnT w="6350" cap="flat" cmpd="sng" algn="ctr">
-                      <a:solidFill>
-                        <a:srgbClr val="E5E7EB"/>
-                      </a:solidFill>
-                      <a:prstDash val="solid"/>
-                      <a:round/>
-                      <a:headEnd type="none" w="med" len="med"/>
-                      <a:tailEnd type="none" w="med" len="med"/>
-                    </a:lnT>
-                    <a:lnB w="6350" cap="flat" cmpd="sng" algn="ctr">
-                      <a:solidFill>
-                        <a:srgbClr val="E5E7EB"/>
-                      </a:solidFill>
-                      <a:prstDash val="solid"/>
-                      <a:round/>
-                      <a:headEnd type="none" w="med" len="med"/>
-                      <a:tailEnd type="none" w="med" len="med"/>
-                    </a:lnB>
-                    <a:solidFill>
                       <a:srgbClr val="FFFFFF"/>
                     </a:solidFill>
                   </a:tcPr>
@@ -8105,7 +8105,7 @@
                           <a:ea typeface="Pretendard" pitchFamily="34" charset="-122"/>
                           <a:cs typeface="Pretendard" pitchFamily="34" charset="-120"/>
                         </a:rPr>
-                        <a:t>"소식지 만들어줘"</a:t>
+                        <a:t>"팔레트·폰트 골라줘"</a:t>
                       </a:r>
                       <a:endParaRPr lang="en-US" sz="1150" dirty="0">
                         <a:latin typeface="Pretendard" charset="0"/>
@@ -8173,7 +8173,7 @@
                           <a:ea typeface="Pretendard" pitchFamily="34" charset="-122"/>
                           <a:cs typeface="Pretendard" pitchFamily="34" charset="-120"/>
                         </a:rPr>
-                        <a:t>소식지/1. 제작 프로세스.md</a:t>
+                        <a:t>1. 작업 가이드/1-3. 색상 팔레트.md · 1-4. 폰트.md</a:t>
                       </a:r>
                       <a:endParaRPr lang="en-US" sz="1100" dirty="0">
                         <a:latin typeface="Pretendard" charset="0"/>
@@ -8237,12 +8237,12 @@
         </p:nvSpPr>
         <p:spPr>
           <a:xfrm>
-            <a:off x="777240" y="5349240"/>
-            <a:ext cx="10637215" cy="777240"/>
+            <a:off x="777240" y="5440680"/>
+            <a:ext cx="10637215" cy="658368"/>
           </a:xfrm>
           <a:prstGeom prst="roundRect">
             <a:avLst>
-              <a:gd name="adj" fmla="val 11765"/>
+              <a:gd name="adj" fmla="val 13889"/>
             </a:avLst>
           </a:prstGeom>
           <a:solidFill>
@@ -8259,8 +8259,8 @@
         </p:nvSpPr>
         <p:spPr>
           <a:xfrm>
-            <a:off x="1051560" y="5440680"/>
-            <a:ext cx="10088575" cy="594360"/>
+            <a:off x="1051560" y="5532120"/>
+            <a:ext cx="10088575" cy="530352"/>
           </a:xfrm>
           <a:prstGeom prst="rect">
             <a:avLst/>
@@ -8287,7 +8287,7 @@
                 <a:ea typeface="Pretendard SemiBold" pitchFamily="34" charset="-122"/>
                 <a:cs typeface="Pretendard SemiBold" pitchFamily="34" charset="-120"/>
               </a:rPr>
-              <a:t>경로 가이드는 이 볼트에서 시킬 수 있는 일 전부를 담되 구분합니다.  </a:t>
+              <a:t>경로 가이드는 이 볼트의 일 전부를 CdBd 기능·Figma 제작·도구로 구분해 담습니다.  </a:t>
             </a:r>
             <a:pPr indent="0" marL="0">
               <a:lnSpc>
@@ -8304,7 +8304,7 @@
                 <a:ea typeface="Pretendard" pitchFamily="34" charset="-122"/>
                 <a:cs typeface="Pretendard" pitchFamily="34" charset="-120"/>
               </a:rPr>
-              <a:t>CdBd 기능 · Figma 제작(디자인 작업) · 도구(로그인·Supabase·image_library.py). 분류표(03장)가 센 것은 이 중 ‘CdBd 기능’만.</a:t>
+              <a:t>이 볼트는 이미 스킬 5종 보유(card-automation·draft 등) → 경로 가이드는 스킬 없는 기능까지 ‘무슨 말→어느 파일’로 잇습니다.</a:t>
             </a:r>
             <a:endParaRPr lang="en-US" sz="1150" dirty="0"/>
           </a:p>
@@ -9823,7 +9823,7 @@
                           <a:ea typeface="Pretendard" pitchFamily="34" charset="-122"/>
                           <a:cs typeface="Pretendard" pitchFamily="34" charset="-120"/>
                         </a:rPr>
-                        <a:t>대분류 3개 확정 · 첫 저장소 = cdbd-design-service</a:t>
+                        <a:t>대분류 3개 확정 · 첫 저장소 = cdbd-templates</a:t>
                       </a:r>
                       <a:endParaRPr lang="en-US" sz="1150" dirty="0">
                         <a:latin typeface="Pretendard" charset="0"/>
@@ -10919,7 +10919,7 @@
                           <a:ea typeface="Pretendard" pitchFamily="34" charset="-122"/>
                           <a:cs typeface="Pretendard" pitchFamily="34" charset="-120"/>
                         </a:rPr>
-                        <a:t>검증 — "이 룩북 CdBd에 올려줘" 테스트</a:t>
+                        <a:t>검증 — "이 템플릿 상세페이지 만들어줘" 테스트</a:t>
                       </a:r>
                       <a:endParaRPr lang="en-US" sz="1150" dirty="0">
                         <a:latin typeface="Pretendard" charset="0"/>
@@ -11386,7 +11386,7 @@
                 <a:ea typeface="Pretendard" pitchFamily="34" charset="-122"/>
                 <a:cs typeface="Pretendard" pitchFamily="34" charset="-120"/>
               </a:rPr>
-              <a:t>① 대분류 = 에디터·어드민·홈페이지 3개로 OK?   ② 첫 저장소 = cdbd-design-service로 OK?</a:t>
+              <a:t>① 대분류 = 에디터·어드민·홈페이지 3개로 OK?   ② 첫 저장소 = cdbd-templates로 OK?</a:t>
             </a:r>
             <a:endParaRPr lang="en-US" sz="1250" dirty="0"/>
           </a:p>

</xml_diff>

<commit_message>
vault backup: 2026-08-11 16:25:16
</commit_message>
<xml_diff>
--- a/_기능별 경로 가이드 — 실행 계획.pptx
+++ b/_기능별 경로 가이드 — 실행 계획.pptx
@@ -20150,12 +20150,12 @@
         </p:nvSpPr>
         <p:spPr>
           <a:xfrm>
-            <a:off x="777240" y="4846320"/>
-            <a:ext cx="10637215" cy="1051560"/>
+            <a:off x="777240" y="4754880"/>
+            <a:ext cx="10637215" cy="1188720"/>
           </a:xfrm>
           <a:prstGeom prst="roundRect">
             <a:avLst>
-              <a:gd name="adj" fmla="val 8696"/>
+              <a:gd name="adj" fmla="val 7692"/>
             </a:avLst>
           </a:prstGeom>
           <a:solidFill>
@@ -20172,8 +20172,8 @@
         </p:nvSpPr>
         <p:spPr>
           <a:xfrm>
-            <a:off x="1051560" y="4956048"/>
-            <a:ext cx="10088575" cy="841248"/>
+            <a:off x="1051560" y="4846320"/>
+            <a:ext cx="10088575" cy="987552"/>
           </a:xfrm>
           <a:prstGeom prst="rect">
             <a:avLst/>
@@ -20187,12 +20187,12 @@
           <a:p>
             <a:pPr indent="0" marL="0">
               <a:lnSpc>
-                <a:spcPct val="135000"/>
+                <a:spcPct val="130000"/>
               </a:lnSpc>
               <a:buNone/>
             </a:pPr>
             <a:r>
-              <a:rPr lang="en-US" sz="1250" dirty="0">
+              <a:rPr lang="en-US" sz="1200" dirty="0">
                 <a:solidFill>
                   <a:srgbClr val="9B7DFF"/>
                 </a:solidFill>
@@ -20200,16 +20200,16 @@
                 <a:ea typeface="Pretendard SemiBold" pitchFamily="34" charset="-122"/>
                 <a:cs typeface="Pretendard SemiBold" pitchFamily="34" charset="-120"/>
               </a:rPr>
-              <a:t>형식 안내  </a:t>
+              <a:t>채우는 원칙  </a:t>
             </a:r>
             <a:pPr indent="0" marL="0">
               <a:lnSpc>
-                <a:spcPct val="135000"/>
+                <a:spcPct val="130000"/>
               </a:lnSpc>
               <a:buNone/>
             </a:pPr>
             <a:r>
-              <a:rPr lang="en-US" sz="1200" dirty="0">
+              <a:rPr lang="en-US" sz="1150" dirty="0">
                 <a:solidFill>
                   <a:srgbClr val="FFFFFF"/>
                 </a:solidFill>
@@ -20217,9 +20217,44 @@
                 <a:ea typeface="Pretendard" pitchFamily="34" charset="-122"/>
                 <a:cs typeface="Pretendard" pitchFamily="34" charset="-120"/>
               </a:rPr>
-              <a:t>영상 파일을 주시면 제가 프레임(정지화면)으로 뽑아 읽습니다. 화면은 보지만 음성(내레이션)은 못 들으니, 핵심 동작이 화면에 보이게(또는 자막) 녹화해 주세요.</a:t>
-            </a:r>
-            <a:endParaRPr lang="en-US" sz="1250" dirty="0"/>
+              <a:t>팀이 실제 쓰는 기능만 문서화 — 안 쓰는 기능(예: 데이터 연결=고객별 개인화)은 ○인 채로 둔다.
+</a:t>
+            </a:r>
+            <a:pPr indent="0" marL="0">
+              <a:lnSpc>
+                <a:spcPct val="130000"/>
+              </a:lnSpc>
+              <a:buNone/>
+            </a:pPr>
+            <a:r>
+              <a:rPr lang="en-US" sz="1200" dirty="0">
+                <a:solidFill>
+                  <a:srgbClr val="9B7DFF"/>
+                </a:solidFill>
+                <a:latin typeface="Pretendard SemiBold" pitchFamily="34" charset="0"/>
+                <a:ea typeface="Pretendard SemiBold" pitchFamily="34" charset="-122"/>
+                <a:cs typeface="Pretendard SemiBold" pitchFamily="34" charset="-120"/>
+              </a:rPr>
+              <a:t>영상 형식  </a:t>
+            </a:r>
+            <a:pPr indent="0" marL="0">
+              <a:lnSpc>
+                <a:spcPct val="130000"/>
+              </a:lnSpc>
+              <a:buNone/>
+            </a:pPr>
+            <a:r>
+              <a:rPr lang="en-US" sz="1150" dirty="0">
+                <a:solidFill>
+                  <a:srgbClr val="FFFFFF"/>
+                </a:solidFill>
+                <a:latin typeface="Pretendard" pitchFamily="34" charset="0"/>
+                <a:ea typeface="Pretendard" pitchFamily="34" charset="-122"/>
+                <a:cs typeface="Pretendard" pitchFamily="34" charset="-120"/>
+              </a:rPr>
+              <a:t>영상을 주시면 프레임으로 뽑아 읽습니다(화면만, 음성 제외). 핵심 화면을 캡처해 주세요.</a:t>
+            </a:r>
+            <a:endParaRPr lang="en-US" sz="1200" dirty="0"/>
           </a:p>
         </p:txBody>
       </p:sp>

</xml_diff>

<commit_message>
vault backup: 2026-08-11 16:31:40
</commit_message>
<xml_diff>
--- a/_기능별 경로 가이드 — 실행 계획.pptx
+++ b/_기능별 경로 가이드 — 실행 계획.pptx
@@ -8811,11 +8811,11 @@
         <p:spPr>
           <a:xfrm>
             <a:off x="777240" y="4160520"/>
-            <a:ext cx="5135728" cy="1783080"/>
+            <a:ext cx="5135728" cy="1536192"/>
           </a:xfrm>
           <a:prstGeom prst="roundRect">
             <a:avLst>
-              <a:gd name="adj" fmla="val 5128"/>
+              <a:gd name="adj" fmla="val 5952"/>
             </a:avLst>
           </a:prstGeom>
           <a:solidFill>
@@ -8979,11 +8979,11 @@
         <p:spPr>
           <a:xfrm>
             <a:off x="6278728" y="4160520"/>
-            <a:ext cx="5135728" cy="1783080"/>
+            <a:ext cx="5135728" cy="1536192"/>
           </a:xfrm>
           <a:prstGeom prst="roundRect">
             <a:avLst>
-              <a:gd name="adj" fmla="val 5128"/>
+              <a:gd name="adj" fmla="val 5952"/>
             </a:avLst>
           </a:prstGeom>
           <a:solidFill>
@@ -9040,7 +9040,7 @@
         <p:spPr>
           <a:xfrm>
             <a:off x="6553048" y="4645152"/>
-            <a:ext cx="4587088" cy="1234440"/>
+            <a:ext cx="4587088" cy="1051560"/>
           </a:xfrm>
           <a:prstGeom prst="rect">
             <a:avLst/>
@@ -9104,6 +9104,59 @@
                 <a:cs typeface="Pretendard" pitchFamily="34" charset="-120"/>
               </a:rPr>
               <a:t>→ 어느 볼트·맨 바깥에서도 로드 · 자동 최신화</a:t>
+            </a:r>
+            <a:endParaRPr lang="en-US" sz="1150" dirty="0"/>
+          </a:p>
+        </p:txBody>
+      </p:sp>
+      <p:sp>
+        <p:nvSpPr>
+          <p:cNvPr id="16" name="Text 14"/>
+          <p:cNvSpPr/>
+          <p:nvPr/>
+        </p:nvSpPr>
+        <p:spPr>
+          <a:xfrm>
+            <a:off x="777240" y="5852160"/>
+            <a:ext cx="10637215" cy="320040"/>
+          </a:xfrm>
+          <a:prstGeom prst="rect">
+            <a:avLst/>
+          </a:prstGeom>
+          <a:noFill/>
+          <a:ln/>
+        </p:spPr>
+        <p:txBody>
+          <a:bodyPr wrap="square" lIns="0" tIns="0" rIns="0" bIns="0" rtlCol="0" anchor="ctr"/>
+          <a:lstStyle/>
+          <a:p>
+            <a:pPr indent="0" marL="0">
+              <a:buNone/>
+            </a:pPr>
+            <a:r>
+              <a:rPr lang="en-US" sz="1150" dirty="0">
+                <a:solidFill>
+                  <a:srgbClr val="6C4CFF"/>
+                </a:solidFill>
+                <a:latin typeface="Pretendard SemiBold" pitchFamily="34" charset="0"/>
+                <a:ea typeface="Pretendard SemiBold" pitchFamily="34" charset="-122"/>
+                <a:cs typeface="Pretendard SemiBold" pitchFamily="34" charset="-120"/>
+              </a:rPr>
+              <a:t>플러그인이 못 담는 것 — 로그인 정보  </a:t>
+            </a:r>
+            <a:pPr indent="0" marL="0">
+              <a:buNone/>
+            </a:pPr>
+            <a:r>
+              <a:rPr lang="en-US" sz="1150" dirty="0">
+                <a:solidFill>
+                  <a:srgbClr val="55555A"/>
+                </a:solidFill>
+                <a:latin typeface="Pretendard" pitchFamily="34" charset="0"/>
+                <a:ea typeface="Pretendard" pitchFamily="34" charset="-122"/>
+                <a:cs typeface="Pretendard" pitchFamily="34" charset="-120"/>
+              </a:rPr>
+              <a:t>→ ONBOARDING에 ‘Claude 셋업’ 챕터 + .env.example로 안내 (비밀 값은 각자 로컬).</a:t>
             </a:r>
             <a:endParaRPr lang="en-US" sz="1150" dirty="0"/>
           </a:p>
@@ -20620,7 +20673,7 @@
                 <a:ea typeface="Pretendard" pitchFamily="34" charset="-122"/>
                 <a:cs typeface="Pretendard" pitchFamily="34" charset="-120"/>
               </a:rPr>
-              <a:t>← 맨 위에 "작업 전 _기능별 경로 가이드.md 읽어라" 1줄
+              <a:t>← 맨 위에 @import(@_기능별 경로 가이드.md) 로 자동 로드
 </a:t>
             </a:r>
             <a:pPr indent="0" marL="0">
@@ -20777,7 +20830,7 @@
                 <a:ea typeface="Pretendard" pitchFamily="34" charset="-122"/>
                 <a:cs typeface="Pretendard" pitchFamily="34" charset="-120"/>
               </a:rPr>
-              <a:t>CLAUDE.md는 폴더 열 때 자동으로 읽는 유일한 파일 → 여기서 가리켜야 읽힌다.</a:t>
+              <a:t>CLAUDE.md에 @import(@_기능별 경로 가이드.md)로 걸면 매 세션 강제 로드 — 포인터의 ‘안 읽을 위험’ 제거.</a:t>
             </a:r>
             <a:endParaRPr lang="en-US" sz="1250" dirty="0"/>
           </a:p>

</xml_diff>